<commit_message>
Ex 2: replace Cowork with in-app Copilots for monthly management paper (Excel/Word/PPT/Outlook); add corporate PPT template; refresh story slide + overview
Co-authored-by: Copilot <223556219+Copilot@users.noreply.github.com>
</commit_message>
<xml_diff>
--- a/Story_Slide_Contoso_Properties.pptx
+++ b/Story_Slide_Contoso_Properties.pptx
@@ -3090,58 +3090,25 @@
       <p:grpSpPr/>
       <p:sp>
         <p:nvSpPr>
-          <p:cNvPr id="2" name="TextBox 1"/>
-          <p:cNvSpPr txBox="1"/>
-          <p:nvPr/>
-        </p:nvSpPr>
-        <p:spPr>
-          <a:xfrm>
-            <a:off x="365760" y="164592"/>
-            <a:ext cx="11430000" cy="292608"/>
-          </a:xfrm>
-          <a:prstGeom prst="rect">
-            <a:avLst/>
-          </a:prstGeom>
-          <a:noFill/>
-        </p:spPr>
-        <p:txBody>
-          <a:bodyPr wrap="square" lIns="0" rIns="0" tIns="0" bIns="0">
-            <a:spAutoFit/>
-          </a:bodyPr>
-          <a:lstStyle/>
-          <a:p>
-            <a:r>
-              <a:rPr sz="1100" b="1" i="0">
-                <a:solidFill>
-                  <a:srgbClr val="64748B"/>
-                </a:solidFill>
-                <a:latin typeface="Calibri"/>
-              </a:rPr>
-              <a:t>Contoso Property Group · GM Copilot Immersion  ·  Integrated Township &amp; Property Development</a:t>
-            </a:r>
-          </a:p>
-        </p:txBody>
-      </p:sp>
-      <p:sp>
-        <p:nvSpPr>
-          <p:cNvPr id="3" name="Rectangle 2"/>
+          <p:cNvPr id="2" name="Rectangle 1"/>
           <p:cNvSpPr/>
           <p:nvPr/>
         </p:nvSpPr>
         <p:spPr>
           <a:xfrm>
-            <a:off x="365760" y="502920"/>
-            <a:ext cx="11475720" cy="1783080"/>
+            <a:off x="0" y="0"/>
+            <a:ext cx="12191695" cy="6858000"/>
           </a:xfrm>
           <a:prstGeom prst="rect">
             <a:avLst/>
           </a:prstGeom>
           <a:solidFill>
-            <a:srgbClr val="0F1D35"/>
+            <a:srgbClr val="FFFFFF"/>
           </a:solidFill>
           <a:ln>
             <a:noFill/>
           </a:ln>
+          <a:effectLst/>
         </p:spPr>
         <p:style>
           <a:lnRef idx="1">
@@ -3167,24 +3134,25 @@
       </p:sp>
       <p:sp>
         <p:nvSpPr>
-          <p:cNvPr id="4" name="Rectangle 3"/>
+          <p:cNvPr id="3" name="Rectangle 2"/>
           <p:cNvSpPr/>
           <p:nvPr/>
         </p:nvSpPr>
         <p:spPr>
           <a:xfrm>
-            <a:off x="365760" y="502920"/>
-            <a:ext cx="11475720" cy="64008"/>
+            <a:off x="0" y="0"/>
+            <a:ext cx="4206240" cy="6858000"/>
           </a:xfrm>
           <a:prstGeom prst="rect">
             <a:avLst/>
           </a:prstGeom>
           <a:solidFill>
-            <a:srgbClr val="0E7C66"/>
+            <a:srgbClr val="0F1F3D"/>
           </a:solidFill>
           <a:ln>
             <a:noFill/>
           </a:ln>
+          <a:effectLst/>
         </p:spPr>
         <p:style>
           <a:lnRef idx="1">
@@ -3210,252 +3178,25 @@
       </p:sp>
       <p:sp>
         <p:nvSpPr>
-          <p:cNvPr id="5" name="TextBox 4"/>
-          <p:cNvSpPr txBox="1"/>
-          <p:nvPr/>
-        </p:nvSpPr>
-        <p:spPr>
-          <a:xfrm>
-            <a:off x="548640" y="685800"/>
-            <a:ext cx="3657600" cy="219456"/>
-          </a:xfrm>
-          <a:prstGeom prst="rect">
-            <a:avLst/>
-          </a:prstGeom>
-          <a:noFill/>
-        </p:spPr>
-        <p:txBody>
-          <a:bodyPr wrap="square" lIns="0" rIns="0" tIns="0" bIns="0">
-            <a:spAutoFit/>
-          </a:bodyPr>
-          <a:lstStyle/>
-          <a:p>
-            <a:r>
-              <a:rPr sz="900" b="1" i="0">
-                <a:solidFill>
-                  <a:srgbClr val="D4A017"/>
-                </a:solidFill>
-                <a:latin typeface="Calibri"/>
-              </a:rPr>
-              <a:t>MICROSOFT 365 COPILOT</a:t>
-            </a:r>
-          </a:p>
-        </p:txBody>
-      </p:sp>
-      <p:sp>
-        <p:nvSpPr>
-          <p:cNvPr id="6" name="TextBox 5"/>
-          <p:cNvSpPr txBox="1"/>
-          <p:nvPr/>
-        </p:nvSpPr>
-        <p:spPr>
-          <a:xfrm>
-            <a:off x="548640" y="914400"/>
-            <a:ext cx="3657600" cy="777240"/>
-          </a:xfrm>
-          <a:prstGeom prst="rect">
-            <a:avLst/>
-          </a:prstGeom>
-          <a:noFill/>
-        </p:spPr>
-        <p:txBody>
-          <a:bodyPr wrap="square" lIns="0" rIns="0" tIns="0" bIns="0">
-            <a:spAutoFit/>
-          </a:bodyPr>
-          <a:lstStyle/>
-          <a:p>
-            <a:r>
-              <a:rPr sz="2200" b="1" i="0">
-                <a:solidFill>
-                  <a:srgbClr val="FFFFFF"/>
-                </a:solidFill>
-                <a:latin typeface="Calibri"/>
-              </a:rPr>
-              <a:t>AI Assistant</a:t>
-            </a:r>
-          </a:p>
-          <a:p>
-            <a:r>
-              <a:rPr sz="2200" b="1" i="0">
-                <a:solidFill>
-                  <a:srgbClr val="FFFFFF"/>
-                </a:solidFill>
-                <a:latin typeface="Calibri"/>
-              </a:rPr>
-              <a:t>to AI Doer</a:t>
-            </a:r>
-          </a:p>
-        </p:txBody>
-      </p:sp>
-      <p:sp>
-        <p:nvSpPr>
-          <p:cNvPr id="7" name="TextBox 6"/>
-          <p:cNvSpPr txBox="1"/>
-          <p:nvPr/>
-        </p:nvSpPr>
-        <p:spPr>
-          <a:xfrm>
-            <a:off x="548640" y="1691640"/>
-            <a:ext cx="3657600" cy="201168"/>
-          </a:xfrm>
-          <a:prstGeom prst="rect">
-            <a:avLst/>
-          </a:prstGeom>
-          <a:noFill/>
-        </p:spPr>
-        <p:txBody>
-          <a:bodyPr wrap="square" lIns="0" rIns="0" tIns="0" bIns="0">
-            <a:spAutoFit/>
-          </a:bodyPr>
-          <a:lstStyle/>
-          <a:p>
-            <a:r>
-              <a:rPr sz="850" b="1" i="0">
-                <a:solidFill>
-                  <a:srgbClr val="D4A017"/>
-                </a:solidFill>
-                <a:latin typeface="Calibri"/>
-              </a:rPr>
-              <a:t>PERSONA</a:t>
-            </a:r>
-          </a:p>
-        </p:txBody>
-      </p:sp>
-      <p:sp>
-        <p:nvSpPr>
-          <p:cNvPr id="8" name="TextBox 7"/>
-          <p:cNvSpPr txBox="1"/>
-          <p:nvPr/>
-        </p:nvSpPr>
-        <p:spPr>
-          <a:xfrm>
-            <a:off x="548640" y="1892808"/>
-            <a:ext cx="3657600" cy="384048"/>
-          </a:xfrm>
-          <a:prstGeom prst="rect">
-            <a:avLst/>
-          </a:prstGeom>
-          <a:noFill/>
-        </p:spPr>
-        <p:txBody>
-          <a:bodyPr wrap="square" lIns="0" rIns="0" tIns="0" bIns="0">
-            <a:spAutoFit/>
-          </a:bodyPr>
-          <a:lstStyle/>
-          <a:p>
-            <a:r>
-              <a:rPr sz="1300" b="1" i="0">
-                <a:solidFill>
-                  <a:srgbClr val="FFFFFF"/>
-                </a:solidFill>
-                <a:latin typeface="Calibri"/>
-              </a:rPr>
-              <a:t>Encik Daniel Tan</a:t>
-            </a:r>
-          </a:p>
-          <a:p>
-            <a:r>
-              <a:rPr sz="1000" b="0" i="0">
-                <a:solidFill>
-                  <a:srgbClr val="CBD5E1"/>
-                </a:solidFill>
-                <a:latin typeface="Calibri"/>
-              </a:rPr>
-              <a:t>General Manager · Township Development · Contoso Property Group</a:t>
-            </a:r>
-          </a:p>
-        </p:txBody>
-      </p:sp>
-      <p:sp>
-        <p:nvSpPr>
-          <p:cNvPr id="9" name="TextBox 8"/>
-          <p:cNvSpPr txBox="1"/>
-          <p:nvPr/>
-        </p:nvSpPr>
-        <p:spPr>
-          <a:xfrm>
-            <a:off x="4370832" y="685800"/>
-            <a:ext cx="3657600" cy="219456"/>
-          </a:xfrm>
-          <a:prstGeom prst="rect">
-            <a:avLst/>
-          </a:prstGeom>
-          <a:noFill/>
-        </p:spPr>
-        <p:txBody>
-          <a:bodyPr wrap="square" lIns="0" rIns="0" tIns="0" bIns="0">
-            <a:spAutoFit/>
-          </a:bodyPr>
-          <a:lstStyle/>
-          <a:p>
-            <a:r>
-              <a:rPr sz="900" b="1" i="0">
-                <a:solidFill>
-                  <a:srgbClr val="D4A017"/>
-                </a:solidFill>
-                <a:latin typeface="Calibri"/>
-              </a:rPr>
-              <a:t>THE MISSION</a:t>
-            </a:r>
-          </a:p>
-        </p:txBody>
-      </p:sp>
-      <p:sp>
-        <p:nvSpPr>
-          <p:cNvPr id="10" name="TextBox 9"/>
-          <p:cNvSpPr txBox="1"/>
-          <p:nvPr/>
-        </p:nvSpPr>
-        <p:spPr>
-          <a:xfrm>
-            <a:off x="4370832" y="914400"/>
-            <a:ext cx="3657600" cy="1325880"/>
-          </a:xfrm>
-          <a:prstGeom prst="rect">
-            <a:avLst/>
-          </a:prstGeom>
-          <a:noFill/>
-        </p:spPr>
-        <p:txBody>
-          <a:bodyPr wrap="square" lIns="0" rIns="0" tIns="0" bIns="0">
-            <a:spAutoFit/>
-          </a:bodyPr>
-          <a:lstStyle/>
-          <a:p>
-            <a:r>
-              <a:rPr sz="1100" b="0" i="0">
-                <a:solidFill>
-                  <a:srgbClr val="CBD5E1"/>
-                </a:solidFill>
-                <a:latin typeface="Calibri"/>
-              </a:rPr>
-              <a:t>Monthly township performance review for the COO: sales take-up, GDV pipeline, construction progress vs schedule, customer NPS, and a land-bank monetisation update — by Friday.</a:t>
-            </a:r>
-          </a:p>
-        </p:txBody>
-      </p:sp>
-      <p:sp>
-        <p:nvSpPr>
-          <p:cNvPr id="11" name="Rectangle 10"/>
+          <p:cNvPr id="4" name="Rectangle 3"/>
           <p:cNvSpPr/>
           <p:nvPr/>
         </p:nvSpPr>
         <p:spPr>
           <a:xfrm>
-            <a:off x="8193024" y="667512"/>
-            <a:ext cx="3611880" cy="1463040"/>
+            <a:off x="4206240" y="0"/>
+            <a:ext cx="38100" cy="6858000"/>
           </a:xfrm>
           <a:prstGeom prst="rect">
             <a:avLst/>
           </a:prstGeom>
           <a:solidFill>
-            <a:srgbClr val="1E2C4A"/>
+            <a:srgbClr val="C4994E"/>
           </a:solidFill>
           <a:ln>
-            <a:solidFill>
-              <a:srgbClr val="334466"/>
-            </a:solidFill>
+            <a:noFill/>
           </a:ln>
+          <a:effectLst/>
         </p:spPr>
         <p:style>
           <a:lnRef idx="1">
@@ -3481,14 +3222,14 @@
       </p:sp>
       <p:sp>
         <p:nvSpPr>
-          <p:cNvPr id="12" name="TextBox 11"/>
+          <p:cNvPr id="5" name="TextBox 4"/>
           <p:cNvSpPr txBox="1"/>
           <p:nvPr/>
         </p:nvSpPr>
         <p:spPr>
           <a:xfrm>
-            <a:off x="8357616" y="777240"/>
-            <a:ext cx="3282696" cy="219456"/>
+            <a:off x="320040" y="365760"/>
+            <a:ext cx="3657600" cy="274320"/>
           </a:xfrm>
           <a:prstGeom prst="rect">
             <a:avLst/>
@@ -3501,28 +3242,29 @@
           </a:bodyPr>
           <a:lstStyle/>
           <a:p>
-            <a:r>
-              <a:rPr sz="900" b="1" i="0">
-                <a:solidFill>
-                  <a:srgbClr val="D4A017"/>
+            <a:pPr algn="l"/>
+            <a:r>
+              <a:rPr sz="1000" b="1" i="0">
+                <a:solidFill>
+                  <a:srgbClr val="C4994E"/>
                 </a:solidFill>
                 <a:latin typeface="Calibri"/>
               </a:rPr>
-              <a:t>THE PUNCHLINE</a:t>
-            </a:r>
-          </a:p>
-        </p:txBody>
-      </p:sp>
-      <p:sp>
-        <p:nvSpPr>
-          <p:cNvPr id="13" name="TextBox 12"/>
+              <a:t>CONTOSO PROPERTY GROUP</a:t>
+            </a:r>
+          </a:p>
+        </p:txBody>
+      </p:sp>
+      <p:sp>
+        <p:nvSpPr>
+          <p:cNvPr id="6" name="TextBox 5"/>
           <p:cNvSpPr txBox="1"/>
           <p:nvPr/>
         </p:nvSpPr>
         <p:spPr>
           <a:xfrm>
-            <a:off x="8357616" y="1005840"/>
-            <a:ext cx="3282696" cy="1097280"/>
+            <a:off x="320040" y="640080"/>
+            <a:ext cx="3657600" cy="274320"/>
           </a:xfrm>
           <a:prstGeom prst="rect">
             <a:avLst/>
@@ -3535,61 +3277,29 @@
           </a:bodyPr>
           <a:lstStyle/>
           <a:p>
-            <a:r>
-              <a:rPr sz="1400" b="1" i="1">
-                <a:solidFill>
-                  <a:srgbClr val="FFFFFF"/>
+            <a:pPr algn="l"/>
+            <a:r>
+              <a:rPr sz="950" b="0" i="1">
+                <a:solidFill>
+                  <a:srgbClr val="94A3B8"/>
                 </a:solidFill>
                 <a:latin typeface="Calibri"/>
               </a:rPr>
-              <a:t>One workday.</a:t>
-            </a:r>
-          </a:p>
-          <a:p>
-            <a:r>
-              <a:rPr sz="1400" b="1" i="1">
-                <a:solidFill>
-                  <a:srgbClr val="FFFFFF"/>
-                </a:solidFill>
-                <a:latin typeface="Calibri"/>
-              </a:rPr>
-              <a:t>Ten Copilot moments.</a:t>
-            </a:r>
-          </a:p>
-          <a:p>
-            <a:r>
-              <a:rPr sz="1300" b="1" i="1">
-                <a:solidFill>
-                  <a:srgbClr val="FFFFFF"/>
-                </a:solidFill>
-                <a:latin typeface="Calibri"/>
-              </a:rPr>
-              <a:t>From morning briefing</a:t>
-            </a:r>
-          </a:p>
-          <a:p>
-            <a:r>
-              <a:rPr sz="1300" b="1" i="1">
-                <a:solidFill>
-                  <a:srgbClr val="FFFFFF"/>
-                </a:solidFill>
-                <a:latin typeface="Calibri"/>
-              </a:rPr>
-              <a:t>to a live HTML dashboard.</a:t>
-            </a:r>
-          </a:p>
-        </p:txBody>
-      </p:sp>
-      <p:sp>
-        <p:nvSpPr>
-          <p:cNvPr id="14" name="TextBox 13"/>
+              <a:t>Microsoft 365 Copilot · Executive Immersion</a:t>
+            </a:r>
+          </a:p>
+        </p:txBody>
+      </p:sp>
+      <p:sp>
+        <p:nvSpPr>
+          <p:cNvPr id="7" name="TextBox 6"/>
           <p:cNvSpPr txBox="1"/>
           <p:nvPr/>
         </p:nvSpPr>
         <p:spPr>
           <a:xfrm>
-            <a:off x="365760" y="2377440"/>
-            <a:ext cx="11475720" cy="274320"/>
+            <a:off x="320040" y="1371600"/>
+            <a:ext cx="3657600" cy="1828800"/>
           </a:xfrm>
           <a:prstGeom prst="rect">
             <a:avLst/>
@@ -3602,40 +3312,346 @@
           </a:bodyPr>
           <a:lstStyle/>
           <a:p>
-            <a:r>
-              <a:rPr sz="1400" b="1" i="0">
-                <a:solidFill>
-                  <a:srgbClr val="1A202C"/>
+            <a:pPr algn="l"/>
+            <a:r>
+              <a:rPr sz="3600" b="1" i="0">
+                <a:solidFill>
+                  <a:srgbClr val="FFFFFF"/>
                 </a:solidFill>
                 <a:latin typeface="Calibri"/>
               </a:rPr>
-              <a:t>Ten Copilot moments across one workday</a:t>
-            </a:r>
-          </a:p>
-        </p:txBody>
-      </p:sp>
-      <p:sp>
-        <p:nvSpPr>
-          <p:cNvPr id="15" name="Rectangle 14"/>
+              <a:t>AI Assistant</a:t>
+            </a:r>
+          </a:p>
+          <a:p>
+            <a:pPr algn="l"/>
+            <a:r>
+              <a:rPr sz="2600" b="0" i="1">
+                <a:solidFill>
+                  <a:srgbClr val="C4994E"/>
+                </a:solidFill>
+                <a:latin typeface="Calibri"/>
+              </a:rPr>
+              <a:t>to</a:t>
+            </a:r>
+          </a:p>
+          <a:p>
+            <a:pPr algn="l"/>
+            <a:r>
+              <a:rPr sz="3600" b="1" i="0">
+                <a:solidFill>
+                  <a:srgbClr val="FFFFFF"/>
+                </a:solidFill>
+                <a:latin typeface="Calibri"/>
+              </a:rPr>
+              <a:t>AI Doer.</a:t>
+            </a:r>
+          </a:p>
+        </p:txBody>
+      </p:sp>
+      <p:sp>
+        <p:nvSpPr>
+          <p:cNvPr id="8" name="TextBox 7"/>
+          <p:cNvSpPr txBox="1"/>
+          <p:nvPr/>
+        </p:nvSpPr>
+        <p:spPr>
+          <a:xfrm>
+            <a:off x="320040" y="4023360"/>
+            <a:ext cx="3657600" cy="274320"/>
+          </a:xfrm>
+          <a:prstGeom prst="rect">
+            <a:avLst/>
+          </a:prstGeom>
+          <a:noFill/>
+        </p:spPr>
+        <p:txBody>
+          <a:bodyPr wrap="square" lIns="0" rIns="0" tIns="0" bIns="0">
+            <a:spAutoFit/>
+          </a:bodyPr>
+          <a:lstStyle/>
+          <a:p>
+            <a:pPr algn="l"/>
+            <a:r>
+              <a:rPr sz="900" b="1" i="0">
+                <a:solidFill>
+                  <a:srgbClr val="C4994E"/>
+                </a:solidFill>
+                <a:latin typeface="Calibri"/>
+              </a:rPr>
+              <a:t>PERSONA</a:t>
+            </a:r>
+          </a:p>
+        </p:txBody>
+      </p:sp>
+      <p:sp>
+        <p:nvSpPr>
+          <p:cNvPr id="9" name="TextBox 8"/>
+          <p:cNvSpPr txBox="1"/>
+          <p:nvPr/>
+        </p:nvSpPr>
+        <p:spPr>
+          <a:xfrm>
+            <a:off x="320040" y="4251960"/>
+            <a:ext cx="3657600" cy="274320"/>
+          </a:xfrm>
+          <a:prstGeom prst="rect">
+            <a:avLst/>
+          </a:prstGeom>
+          <a:noFill/>
+        </p:spPr>
+        <p:txBody>
+          <a:bodyPr wrap="square" lIns="0" rIns="0" tIns="0" bIns="0">
+            <a:spAutoFit/>
+          </a:bodyPr>
+          <a:lstStyle/>
+          <a:p>
+            <a:pPr algn="l"/>
+            <a:r>
+              <a:rPr sz="1400" b="1" i="0">
+                <a:solidFill>
+                  <a:srgbClr val="FFFFFF"/>
+                </a:solidFill>
+                <a:latin typeface="Calibri"/>
+              </a:rPr>
+              <a:t>Encik Daniel Tan</a:t>
+            </a:r>
+          </a:p>
+        </p:txBody>
+      </p:sp>
+      <p:sp>
+        <p:nvSpPr>
+          <p:cNvPr id="10" name="TextBox 9"/>
+          <p:cNvSpPr txBox="1"/>
+          <p:nvPr/>
+        </p:nvSpPr>
+        <p:spPr>
+          <a:xfrm>
+            <a:off x="320040" y="4480560"/>
+            <a:ext cx="3657600" cy="365760"/>
+          </a:xfrm>
+          <a:prstGeom prst="rect">
+            <a:avLst/>
+          </a:prstGeom>
+          <a:noFill/>
+        </p:spPr>
+        <p:txBody>
+          <a:bodyPr wrap="square" lIns="0" rIns="0" tIns="0" bIns="0">
+            <a:spAutoFit/>
+          </a:bodyPr>
+          <a:lstStyle/>
+          <a:p>
+            <a:pPr algn="l"/>
+            <a:r>
+              <a:rPr sz="1000" b="0" i="0">
+                <a:solidFill>
+                  <a:srgbClr val="94A3B8"/>
+                </a:solidFill>
+                <a:latin typeface="Calibri"/>
+              </a:rPr>
+              <a:t>General Manager · Township Development</a:t>
+            </a:r>
+          </a:p>
+        </p:txBody>
+      </p:sp>
+      <p:sp>
+        <p:nvSpPr>
+          <p:cNvPr id="11" name="TextBox 10"/>
+          <p:cNvSpPr txBox="1"/>
+          <p:nvPr/>
+        </p:nvSpPr>
+        <p:spPr>
+          <a:xfrm>
+            <a:off x="320040" y="5029200"/>
+            <a:ext cx="3657600" cy="274320"/>
+          </a:xfrm>
+          <a:prstGeom prst="rect">
+            <a:avLst/>
+          </a:prstGeom>
+          <a:noFill/>
+        </p:spPr>
+        <p:txBody>
+          <a:bodyPr wrap="square" lIns="0" rIns="0" tIns="0" bIns="0">
+            <a:spAutoFit/>
+          </a:bodyPr>
+          <a:lstStyle/>
+          <a:p>
+            <a:pPr algn="l"/>
+            <a:r>
+              <a:rPr sz="900" b="1" i="0">
+                <a:solidFill>
+                  <a:srgbClr val="C4994E"/>
+                </a:solidFill>
+                <a:latin typeface="Calibri"/>
+              </a:rPr>
+              <a:t>THE MISSION</a:t>
+            </a:r>
+          </a:p>
+        </p:txBody>
+      </p:sp>
+      <p:sp>
+        <p:nvSpPr>
+          <p:cNvPr id="12" name="TextBox 11"/>
+          <p:cNvSpPr txBox="1"/>
+          <p:nvPr/>
+        </p:nvSpPr>
+        <p:spPr>
+          <a:xfrm>
+            <a:off x="320040" y="5257800"/>
+            <a:ext cx="3657600" cy="1280160"/>
+          </a:xfrm>
+          <a:prstGeom prst="rect">
+            <a:avLst/>
+          </a:prstGeom>
+          <a:noFill/>
+        </p:spPr>
+        <p:txBody>
+          <a:bodyPr wrap="square" lIns="0" rIns="0" tIns="0" bIns="0">
+            <a:spAutoFit/>
+          </a:bodyPr>
+          <a:lstStyle/>
+          <a:p>
+            <a:pPr algn="l"/>
+            <a:r>
+              <a:rPr sz="1100" b="0" i="0">
+                <a:solidFill>
+                  <a:srgbClr val="CBD5E1"/>
+                </a:solidFill>
+                <a:latin typeface="Calibri"/>
+              </a:rPr>
+              <a:t>Deliver the monthly Operating Committee management paper — KPIs, wins, issues, asks — board-ready by Friday.</a:t>
+            </a:r>
+          </a:p>
+        </p:txBody>
+      </p:sp>
+      <p:sp>
+        <p:nvSpPr>
+          <p:cNvPr id="13" name="TextBox 12"/>
+          <p:cNvSpPr txBox="1"/>
+          <p:nvPr/>
+        </p:nvSpPr>
+        <p:spPr>
+          <a:xfrm>
+            <a:off x="4572000" y="411480"/>
+            <a:ext cx="7315200" cy="365760"/>
+          </a:xfrm>
+          <a:prstGeom prst="rect">
+            <a:avLst/>
+          </a:prstGeom>
+          <a:noFill/>
+        </p:spPr>
+        <p:txBody>
+          <a:bodyPr wrap="square" lIns="0" rIns="0" tIns="0" bIns="0">
+            <a:spAutoFit/>
+          </a:bodyPr>
+          <a:lstStyle/>
+          <a:p>
+            <a:pPr algn="l"/>
+            <a:r>
+              <a:rPr sz="1100" b="1" i="0">
+                <a:solidFill>
+                  <a:srgbClr val="0F1F3D"/>
+                </a:solidFill>
+                <a:latin typeface="Calibri"/>
+              </a:rPr>
+              <a:t>ONE WORKDAY  ·  TEN COPILOT MOMENTS</a:t>
+            </a:r>
+          </a:p>
+        </p:txBody>
+      </p:sp>
+      <p:sp>
+        <p:nvSpPr>
+          <p:cNvPr id="14" name="TextBox 13"/>
+          <p:cNvSpPr txBox="1"/>
+          <p:nvPr/>
+        </p:nvSpPr>
+        <p:spPr>
+          <a:xfrm>
+            <a:off x="4572000" y="713232"/>
+            <a:ext cx="7315200" cy="457200"/>
+          </a:xfrm>
+          <a:prstGeom prst="rect">
+            <a:avLst/>
+          </a:prstGeom>
+          <a:noFill/>
+        </p:spPr>
+        <p:txBody>
+          <a:bodyPr wrap="square" lIns="0" rIns="0" tIns="0" bIns="0">
+            <a:spAutoFit/>
+          </a:bodyPr>
+          <a:lstStyle/>
+          <a:p>
+            <a:pPr algn="l"/>
+            <a:r>
+              <a:rPr sz="1600" b="1" i="0">
+                <a:solidFill>
+                  <a:srgbClr val="1A202C"/>
+                </a:solidFill>
+                <a:latin typeface="Calibri"/>
+              </a:rPr>
+              <a:t>From morning briefing to a board-ready management paper.</a:t>
+            </a:r>
+          </a:p>
+        </p:txBody>
+      </p:sp>
+      <p:sp>
+        <p:nvSpPr>
+          <p:cNvPr id="15" name="TextBox 14"/>
+          <p:cNvSpPr txBox="1"/>
+          <p:nvPr/>
+        </p:nvSpPr>
+        <p:spPr>
+          <a:xfrm>
+            <a:off x="4572000" y="1078992"/>
+            <a:ext cx="7315200" cy="365760"/>
+          </a:xfrm>
+          <a:prstGeom prst="rect">
+            <a:avLst/>
+          </a:prstGeom>
+          <a:noFill/>
+        </p:spPr>
+        <p:txBody>
+          <a:bodyPr wrap="square" lIns="0" rIns="0" tIns="0" bIns="0">
+            <a:spAutoFit/>
+          </a:bodyPr>
+          <a:lstStyle/>
+          <a:p>
+            <a:pPr algn="l"/>
+            <a:r>
+              <a:rPr sz="1100" b="0" i="1">
+                <a:solidFill>
+                  <a:srgbClr val="94A3B8"/>
+                </a:solidFill>
+                <a:latin typeface="Calibri"/>
+              </a:rPr>
+              <a:t>Every artefact stays in the tenant. The GM owns every step.</a:t>
+            </a:r>
+          </a:p>
+        </p:txBody>
+      </p:sp>
+      <p:sp>
+        <p:nvSpPr>
+          <p:cNvPr id="16" name="Rounded Rectangle 15"/>
           <p:cNvSpPr/>
           <p:nvPr/>
         </p:nvSpPr>
         <p:spPr>
           <a:xfrm>
-            <a:off x="365760" y="2743200"/>
-            <a:ext cx="2782747" cy="1243584"/>
-          </a:xfrm>
-          <a:prstGeom prst="rect">
+            <a:off x="4572000" y="1691640"/>
+            <a:ext cx="7315200" cy="1078992"/>
+          </a:xfrm>
+          <a:prstGeom prst="roundRect">
             <a:avLst/>
           </a:prstGeom>
           <a:solidFill>
             <a:srgbClr val="F8FAFC"/>
           </a:solidFill>
-          <a:ln>
+          <a:ln w="6350">
             <a:solidFill>
-              <a:srgbClr val="D9DFE9"/>
+              <a:srgbClr val="D1D9E6"/>
             </a:solidFill>
           </a:ln>
+          <a:effectLst/>
         </p:spPr>
         <p:style>
           <a:lnRef idx="1">
@@ -3661,24 +3677,25 @@
       </p:sp>
       <p:sp>
         <p:nvSpPr>
-          <p:cNvPr id="16" name="Rectangle 15"/>
+          <p:cNvPr id="17" name="Rounded Rectangle 16"/>
           <p:cNvSpPr/>
           <p:nvPr/>
         </p:nvSpPr>
         <p:spPr>
           <a:xfrm>
-            <a:off x="365760" y="2743200"/>
-            <a:ext cx="2782747" cy="365760"/>
-          </a:xfrm>
-          <a:prstGeom prst="rect">
+            <a:off x="4572000" y="1691640"/>
+            <a:ext cx="822960" cy="1078992"/>
+          </a:xfrm>
+          <a:prstGeom prst="roundRect">
             <a:avLst/>
           </a:prstGeom>
           <a:solidFill>
-            <a:srgbClr val="0E7490"/>
+            <a:srgbClr val="0F1F3D"/>
           </a:solidFill>
           <a:ln>
             <a:noFill/>
           </a:ln>
+          <a:effectLst/>
         </p:spPr>
         <p:style>
           <a:lnRef idx="1">
@@ -3704,14 +3721,14 @@
       </p:sp>
       <p:sp>
         <p:nvSpPr>
-          <p:cNvPr id="17" name="TextBox 16"/>
+          <p:cNvPr id="18" name="TextBox 17"/>
           <p:cNvSpPr txBox="1"/>
           <p:nvPr/>
         </p:nvSpPr>
         <p:spPr>
           <a:xfrm>
-            <a:off x="457200" y="2788920"/>
-            <a:ext cx="2599867" cy="320040"/>
+            <a:off x="4572000" y="1691640"/>
+            <a:ext cx="822960" cy="1078992"/>
           </a:xfrm>
           <a:prstGeom prst="rect">
             <a:avLst/>
@@ -3719,33 +3736,34 @@
           <a:noFill/>
         </p:spPr>
         <p:txBody>
-          <a:bodyPr wrap="square" lIns="0" rIns="0" tIns="0" bIns="0">
+          <a:bodyPr wrap="square" lIns="0" rIns="0" tIns="0" bIns="0" anchor="ctr">
             <a:spAutoFit/>
           </a:bodyPr>
           <a:lstStyle/>
           <a:p>
-            <a:r>
-              <a:rPr sz="1100" b="1" i="0">
-                <a:solidFill>
-                  <a:srgbClr val="FFFFFF"/>
+            <a:pPr algn="ctr"/>
+            <a:r>
+              <a:rPr sz="2600" b="1" i="0">
+                <a:solidFill>
+                  <a:srgbClr val="C4994E"/>
                 </a:solidFill>
                 <a:latin typeface="Calibri"/>
               </a:rPr>
-              <a:t>01   Daily Briefing</a:t>
-            </a:r>
-          </a:p>
-        </p:txBody>
-      </p:sp>
-      <p:sp>
-        <p:nvSpPr>
-          <p:cNvPr id="18" name="TextBox 17"/>
+              <a:t>01</a:t>
+            </a:r>
+          </a:p>
+        </p:txBody>
+      </p:sp>
+      <p:sp>
+        <p:nvSpPr>
+          <p:cNvPr id="19" name="TextBox 18"/>
           <p:cNvSpPr txBox="1"/>
           <p:nvPr/>
         </p:nvSpPr>
         <p:spPr>
           <a:xfrm>
-            <a:off x="475488" y="3182112"/>
-            <a:ext cx="2563291" cy="292608"/>
+            <a:off x="5532120" y="1801368"/>
+            <a:ext cx="4114800" cy="320040"/>
           </a:xfrm>
           <a:prstGeom prst="rect">
             <a:avLst/>
@@ -3758,28 +3776,29 @@
           </a:bodyPr>
           <a:lstStyle/>
           <a:p>
-            <a:r>
-              <a:rPr sz="1200" b="1" i="0">
-                <a:solidFill>
-                  <a:srgbClr val="1A202C"/>
+            <a:pPr algn="l"/>
+            <a:r>
+              <a:rPr sz="1100" b="1" i="0">
+                <a:solidFill>
+                  <a:srgbClr val="0F1F3D"/>
                 </a:solidFill>
                 <a:latin typeface="Calibri"/>
               </a:rPr>
-              <a:t>Morning brief in 3 minutes</a:t>
-            </a:r>
-          </a:p>
-        </p:txBody>
-      </p:sp>
-      <p:sp>
-        <p:nvSpPr>
-          <p:cNvPr id="19" name="TextBox 18"/>
+              <a:t>MORNING BRIEFING</a:t>
+            </a:r>
+          </a:p>
+        </p:txBody>
+      </p:sp>
+      <p:sp>
+        <p:nvSpPr>
+          <p:cNvPr id="20" name="TextBox 19"/>
           <p:cNvSpPr txBox="1"/>
           <p:nvPr/>
         </p:nvSpPr>
         <p:spPr>
           <a:xfrm>
-            <a:off x="475488" y="3493008"/>
-            <a:ext cx="2563291" cy="219456"/>
+            <a:off x="5532120" y="2075688"/>
+            <a:ext cx="6263640" cy="502920"/>
           </a:xfrm>
           <a:prstGeom prst="rect">
             <a:avLst/>
@@ -3792,28 +3811,29 @@
           </a:bodyPr>
           <a:lstStyle/>
           <a:p>
-            <a:r>
-              <a:rPr sz="950" b="0" i="1">
-                <a:solidFill>
-                  <a:srgbClr val="0E7490"/>
+            <a:pPr algn="l"/>
+            <a:r>
+              <a:rPr sz="1050" b="0" i="0">
+                <a:solidFill>
+                  <a:srgbClr val="1A202C"/>
                 </a:solidFill>
                 <a:latin typeface="Calibri"/>
               </a:rPr>
-              <a:t>Researcher · Critique</a:t>
-            </a:r>
-          </a:p>
-        </p:txBody>
-      </p:sp>
-      <p:sp>
-        <p:nvSpPr>
-          <p:cNvPr id="20" name="TextBox 19"/>
+              <a:t>Researcher with Critique drafts the daily brief; translates Bahasa Indonesia content into English; self-reviews sources.</a:t>
+            </a:r>
+          </a:p>
+        </p:txBody>
+      </p:sp>
+      <p:sp>
+        <p:nvSpPr>
+          <p:cNvPr id="21" name="TextBox 20"/>
           <p:cNvSpPr txBox="1"/>
           <p:nvPr/>
         </p:nvSpPr>
         <p:spPr>
           <a:xfrm>
-            <a:off x="475488" y="3749040"/>
-            <a:ext cx="2563291" cy="219456"/>
+            <a:off x="5532120" y="2450592"/>
+            <a:ext cx="6263640" cy="274320"/>
           </a:xfrm>
           <a:prstGeom prst="rect">
             <a:avLst/>
@@ -3826,40 +3846,42 @@
           </a:bodyPr>
           <a:lstStyle/>
           <a:p>
-            <a:r>
-              <a:rPr sz="1000" b="0" i="0">
-                <a:solidFill>
-                  <a:srgbClr val="64748B"/>
+            <a:pPr algn="l"/>
+            <a:r>
+              <a:rPr sz="950" b="1" i="1">
+                <a:solidFill>
+                  <a:srgbClr val="C4994E"/>
                 </a:solidFill>
                 <a:latin typeface="Calibri"/>
               </a:rPr>
-              <a:t>Researcher (Critique) drafts a market &amp; peer scan and self-reviews sources before delivering one polished brief.</a:t>
-            </a:r>
-          </a:p>
-        </p:txBody>
-      </p:sp>
-      <p:sp>
-        <p:nvSpPr>
-          <p:cNvPr id="21" name="Rectangle 20"/>
+              <a:t>Researcher · Critique</a:t>
+            </a:r>
+          </a:p>
+        </p:txBody>
+      </p:sp>
+      <p:sp>
+        <p:nvSpPr>
+          <p:cNvPr id="22" name="Rounded Rectangle 21"/>
           <p:cNvSpPr/>
           <p:nvPr/>
         </p:nvSpPr>
         <p:spPr>
           <a:xfrm>
-            <a:off x="3258235" y="2743200"/>
-            <a:ext cx="2782747" cy="1243584"/>
-          </a:xfrm>
-          <a:prstGeom prst="rect">
+            <a:off x="4572000" y="2880360"/>
+            <a:ext cx="7315200" cy="1078992"/>
+          </a:xfrm>
+          <a:prstGeom prst="roundRect">
             <a:avLst/>
           </a:prstGeom>
           <a:solidFill>
             <a:srgbClr val="F8FAFC"/>
           </a:solidFill>
-          <a:ln>
+          <a:ln w="6350">
             <a:solidFill>
-              <a:srgbClr val="D9DFE9"/>
+              <a:srgbClr val="D1D9E6"/>
             </a:solidFill>
           </a:ln>
+          <a:effectLst/>
         </p:spPr>
         <p:style>
           <a:lnRef idx="1">
@@ -3885,24 +3907,25 @@
       </p:sp>
       <p:sp>
         <p:nvSpPr>
-          <p:cNvPr id="22" name="Rectangle 21"/>
+          <p:cNvPr id="23" name="Rounded Rectangle 22"/>
           <p:cNvSpPr/>
           <p:nvPr/>
         </p:nvSpPr>
         <p:spPr>
           <a:xfrm>
-            <a:off x="3258235" y="2743200"/>
-            <a:ext cx="2782747" cy="365760"/>
-          </a:xfrm>
-          <a:prstGeom prst="rect">
+            <a:off x="4572000" y="2880360"/>
+            <a:ext cx="822960" cy="1078992"/>
+          </a:xfrm>
+          <a:prstGeom prst="roundRect">
             <a:avLst/>
           </a:prstGeom>
           <a:solidFill>
-            <a:srgbClr val="0F766E"/>
+            <a:srgbClr val="0F1F3D"/>
           </a:solidFill>
           <a:ln>
             <a:noFill/>
           </a:ln>
+          <a:effectLst/>
         </p:spPr>
         <p:style>
           <a:lnRef idx="1">
@@ -3928,14 +3951,14 @@
       </p:sp>
       <p:sp>
         <p:nvSpPr>
-          <p:cNvPr id="23" name="TextBox 22"/>
+          <p:cNvPr id="24" name="TextBox 23"/>
           <p:cNvSpPr txBox="1"/>
           <p:nvPr/>
         </p:nvSpPr>
         <p:spPr>
           <a:xfrm>
-            <a:off x="3349675" y="2788920"/>
-            <a:ext cx="2599867" cy="320040"/>
+            <a:off x="4572000" y="2880360"/>
+            <a:ext cx="822960" cy="1078992"/>
           </a:xfrm>
           <a:prstGeom prst="rect">
             <a:avLst/>
@@ -3943,33 +3966,34 @@
           <a:noFill/>
         </p:spPr>
         <p:txBody>
-          <a:bodyPr wrap="square" lIns="0" rIns="0" tIns="0" bIns="0">
+          <a:bodyPr wrap="square" lIns="0" rIns="0" tIns="0" bIns="0" anchor="ctr">
             <a:spAutoFit/>
           </a:bodyPr>
           <a:lstStyle/>
           <a:p>
-            <a:r>
-              <a:rPr sz="1100" b="1" i="0">
-                <a:solidFill>
-                  <a:srgbClr val="FFFFFF"/>
+            <a:pPr algn="ctr"/>
+            <a:r>
+              <a:rPr sz="2600" b="1" i="0">
+                <a:solidFill>
+                  <a:srgbClr val="C4994E"/>
                 </a:solidFill>
                 <a:latin typeface="Calibri"/>
               </a:rPr>
-              <a:t>02   Quarter Closing</a:t>
-            </a:r>
-          </a:p>
-        </p:txBody>
-      </p:sp>
-      <p:sp>
-        <p:nvSpPr>
-          <p:cNvPr id="24" name="TextBox 23"/>
+              <a:t>02</a:t>
+            </a:r>
+          </a:p>
+        </p:txBody>
+      </p:sp>
+      <p:sp>
+        <p:nvSpPr>
+          <p:cNvPr id="25" name="TextBox 24"/>
           <p:cNvSpPr txBox="1"/>
           <p:nvPr/>
         </p:nvSpPr>
         <p:spPr>
           <a:xfrm>
-            <a:off x="3367963" y="3182112"/>
-            <a:ext cx="2563291" cy="292608"/>
+            <a:off x="5532120" y="2990088"/>
+            <a:ext cx="4114800" cy="320040"/>
           </a:xfrm>
           <a:prstGeom prst="rect">
             <a:avLst/>
@@ -3982,28 +4006,29 @@
           </a:bodyPr>
           <a:lstStyle/>
           <a:p>
-            <a:r>
-              <a:rPr sz="1200" b="1" i="0">
-                <a:solidFill>
-                  <a:srgbClr val="1A202C"/>
+            <a:pPr algn="l"/>
+            <a:r>
+              <a:rPr sz="1100" b="1" i="0">
+                <a:solidFill>
+                  <a:srgbClr val="0F1F3D"/>
                 </a:solidFill>
                 <a:latin typeface="Calibri"/>
               </a:rPr>
-              <a:t>Multi-step quarter-close prep</a:t>
-            </a:r>
-          </a:p>
-        </p:txBody>
-      </p:sp>
-      <p:sp>
-        <p:nvSpPr>
-          <p:cNvPr id="25" name="TextBox 24"/>
+              <a:t>MANAGEMENT PAPER</a:t>
+            </a:r>
+          </a:p>
+        </p:txBody>
+      </p:sp>
+      <p:sp>
+        <p:nvSpPr>
+          <p:cNvPr id="26" name="TextBox 25"/>
           <p:cNvSpPr txBox="1"/>
           <p:nvPr/>
         </p:nvSpPr>
         <p:spPr>
           <a:xfrm>
-            <a:off x="3367963" y="3493008"/>
-            <a:ext cx="2563291" cy="219456"/>
+            <a:off x="5532120" y="3264408"/>
+            <a:ext cx="6263640" cy="502920"/>
           </a:xfrm>
           <a:prstGeom prst="rect">
             <a:avLst/>
@@ -4016,28 +4041,29 @@
           </a:bodyPr>
           <a:lstStyle/>
           <a:p>
-            <a:r>
-              <a:rPr sz="950" b="0" i="1">
-                <a:solidFill>
-                  <a:srgbClr val="0F766E"/>
+            <a:pPr algn="l"/>
+            <a:r>
+              <a:rPr sz="1050" b="0" i="0">
+                <a:solidFill>
+                  <a:srgbClr val="1A202C"/>
                 </a:solidFill>
                 <a:latin typeface="Calibri"/>
               </a:rPr>
-              <a:t>Cowork</a:t>
-            </a:r>
-          </a:p>
-        </p:txBody>
-      </p:sp>
-      <p:sp>
-        <p:nvSpPr>
-          <p:cNvPr id="26" name="TextBox 25"/>
+              <a:t>Four in-app Copilots: Excel does the numbers, Word writes the paper, PowerPoint turns it into a deck, Outlook sends the cascade.</a:t>
+            </a:r>
+          </a:p>
+        </p:txBody>
+      </p:sp>
+      <p:sp>
+        <p:nvSpPr>
+          <p:cNvPr id="27" name="TextBox 26"/>
           <p:cNvSpPr txBox="1"/>
           <p:nvPr/>
         </p:nvSpPr>
         <p:spPr>
           <a:xfrm>
-            <a:off x="3367963" y="3749040"/>
-            <a:ext cx="2563291" cy="219456"/>
+            <a:off x="5532120" y="3639312"/>
+            <a:ext cx="6263640" cy="274320"/>
           </a:xfrm>
           <a:prstGeom prst="rect">
             <a:avLst/>
@@ -4050,40 +4076,42 @@
           </a:bodyPr>
           <a:lstStyle/>
           <a:p>
-            <a:r>
-              <a:rPr sz="1000" b="0" i="0">
-                <a:solidFill>
-                  <a:srgbClr val="64748B"/>
+            <a:pPr algn="l"/>
+            <a:r>
+              <a:rPr sz="950" b="1" i="1">
+                <a:solidFill>
+                  <a:srgbClr val="C4994E"/>
                 </a:solidFill>
                 <a:latin typeface="Calibri"/>
               </a:rPr>
-              <a:t>Cowork pulls KPIs, the strategic memo and brand pack into a quarter-closing pre-read in one prompt.</a:t>
-            </a:r>
-          </a:p>
-        </p:txBody>
-      </p:sp>
-      <p:sp>
-        <p:nvSpPr>
-          <p:cNvPr id="27" name="Rectangle 26"/>
+              <a:t>Excel · Word · PPT · Outlook</a:t>
+            </a:r>
+          </a:p>
+        </p:txBody>
+      </p:sp>
+      <p:sp>
+        <p:nvSpPr>
+          <p:cNvPr id="28" name="Rounded Rectangle 27"/>
           <p:cNvSpPr/>
           <p:nvPr/>
         </p:nvSpPr>
         <p:spPr>
           <a:xfrm>
-            <a:off x="6150711" y="2743200"/>
-            <a:ext cx="2782747" cy="1243584"/>
-          </a:xfrm>
-          <a:prstGeom prst="rect">
+            <a:off x="4572000" y="4069080"/>
+            <a:ext cx="7315200" cy="1078992"/>
+          </a:xfrm>
+          <a:prstGeom prst="roundRect">
             <a:avLst/>
           </a:prstGeom>
           <a:solidFill>
             <a:srgbClr val="F8FAFC"/>
           </a:solidFill>
-          <a:ln>
+          <a:ln w="6350">
             <a:solidFill>
-              <a:srgbClr val="D9DFE9"/>
+              <a:srgbClr val="D1D9E6"/>
             </a:solidFill>
           </a:ln>
+          <a:effectLst/>
         </p:spPr>
         <p:style>
           <a:lnRef idx="1">
@@ -4109,24 +4137,25 @@
       </p:sp>
       <p:sp>
         <p:nvSpPr>
-          <p:cNvPr id="28" name="Rectangle 27"/>
+          <p:cNvPr id="29" name="Rounded Rectangle 28"/>
           <p:cNvSpPr/>
           <p:nvPr/>
         </p:nvSpPr>
         <p:spPr>
           <a:xfrm>
-            <a:off x="6150711" y="2743200"/>
-            <a:ext cx="2782747" cy="365760"/>
-          </a:xfrm>
-          <a:prstGeom prst="rect">
+            <a:off x="4572000" y="4069080"/>
+            <a:ext cx="822960" cy="1078992"/>
+          </a:xfrm>
+          <a:prstGeom prst="roundRect">
             <a:avLst/>
           </a:prstGeom>
           <a:solidFill>
-            <a:srgbClr val="155E75"/>
+            <a:srgbClr val="0F1F3D"/>
           </a:solidFill>
           <a:ln>
             <a:noFill/>
           </a:ln>
+          <a:effectLst/>
         </p:spPr>
         <p:style>
           <a:lnRef idx="1">
@@ -4152,14 +4181,14 @@
       </p:sp>
       <p:sp>
         <p:nvSpPr>
-          <p:cNvPr id="29" name="TextBox 28"/>
+          <p:cNvPr id="30" name="TextBox 29"/>
           <p:cNvSpPr txBox="1"/>
           <p:nvPr/>
         </p:nvSpPr>
         <p:spPr>
           <a:xfrm>
-            <a:off x="6242151" y="2788920"/>
-            <a:ext cx="2599867" cy="320040"/>
+            <a:off x="4572000" y="4069080"/>
+            <a:ext cx="822960" cy="1078992"/>
           </a:xfrm>
           <a:prstGeom prst="rect">
             <a:avLst/>
@@ -4167,33 +4196,34 @@
           <a:noFill/>
         </p:spPr>
         <p:txBody>
-          <a:bodyPr wrap="square" lIns="0" rIns="0" tIns="0" bIns="0">
+          <a:bodyPr wrap="square" lIns="0" rIns="0" tIns="0" bIns="0" anchor="ctr">
             <a:spAutoFit/>
           </a:bodyPr>
           <a:lstStyle/>
           <a:p>
-            <a:r>
-              <a:rPr sz="1100" b="1" i="0">
-                <a:solidFill>
-                  <a:srgbClr val="FFFFFF"/>
+            <a:pPr algn="ctr"/>
+            <a:r>
+              <a:rPr sz="2600" b="1" i="0">
+                <a:solidFill>
+                  <a:srgbClr val="C4994E"/>
                 </a:solidFill>
                 <a:latin typeface="Calibri"/>
               </a:rPr>
-              <a:t>03   Market Intelligence</a:t>
-            </a:r>
-          </a:p>
-        </p:txBody>
-      </p:sp>
-      <p:sp>
-        <p:nvSpPr>
-          <p:cNvPr id="30" name="TextBox 29"/>
+              <a:t>03</a:t>
+            </a:r>
+          </a:p>
+        </p:txBody>
+      </p:sp>
+      <p:sp>
+        <p:nvSpPr>
+          <p:cNvPr id="31" name="TextBox 30"/>
           <p:cNvSpPr txBox="1"/>
           <p:nvPr/>
         </p:nvSpPr>
         <p:spPr>
           <a:xfrm>
-            <a:off x="6260439" y="3182112"/>
-            <a:ext cx="2563291" cy="292608"/>
+            <a:off x="5532120" y="4178808"/>
+            <a:ext cx="4114800" cy="320040"/>
           </a:xfrm>
           <a:prstGeom prst="rect">
             <a:avLst/>
@@ -4206,28 +4236,29 @@
           </a:bodyPr>
           <a:lstStyle/>
           <a:p>
-            <a:r>
-              <a:rPr sz="1200" b="1" i="0">
-                <a:solidFill>
-                  <a:srgbClr val="1A202C"/>
+            <a:pPr algn="l"/>
+            <a:r>
+              <a:rPr sz="1100" b="1" i="0">
+                <a:solidFill>
+                  <a:srgbClr val="0F1F3D"/>
                 </a:solidFill>
                 <a:latin typeface="Calibri"/>
               </a:rPr>
-              <a:t>Critique &amp; Model Council</a:t>
-            </a:r>
-          </a:p>
-        </p:txBody>
-      </p:sp>
-      <p:sp>
-        <p:nvSpPr>
-          <p:cNvPr id="31" name="TextBox 30"/>
+              <a:t>MARKET INTELLIGENCE</a:t>
+            </a:r>
+          </a:p>
+        </p:txBody>
+      </p:sp>
+      <p:sp>
+        <p:nvSpPr>
+          <p:cNvPr id="32" name="TextBox 31"/>
           <p:cNvSpPr txBox="1"/>
           <p:nvPr/>
         </p:nvSpPr>
         <p:spPr>
           <a:xfrm>
-            <a:off x="6260439" y="3493008"/>
-            <a:ext cx="2563291" cy="219456"/>
+            <a:off x="5532120" y="4453128"/>
+            <a:ext cx="6263640" cy="502920"/>
           </a:xfrm>
           <a:prstGeom prst="rect">
             <a:avLst/>
@@ -4240,28 +4271,29 @@
           </a:bodyPr>
           <a:lstStyle/>
           <a:p>
-            <a:r>
-              <a:rPr sz="950" b="0" i="1">
-                <a:solidFill>
-                  <a:srgbClr val="155E75"/>
+            <a:pPr algn="l"/>
+            <a:r>
+              <a:rPr sz="1050" b="0" i="0">
+                <a:solidFill>
+                  <a:srgbClr val="1A202C"/>
                 </a:solidFill>
                 <a:latin typeface="Calibri"/>
               </a:rPr>
-              <a:t>Researcher</a:t>
-            </a:r>
-          </a:p>
-        </p:txBody>
-      </p:sp>
-      <p:sp>
-        <p:nvSpPr>
-          <p:cNvPr id="32" name="TextBox 31"/>
+              <a:t>Run a Critique pass and a Model Council on the same market question — two answers compared, the stronger one chosen.</a:t>
+            </a:r>
+          </a:p>
+        </p:txBody>
+      </p:sp>
+      <p:sp>
+        <p:nvSpPr>
+          <p:cNvPr id="33" name="TextBox 32"/>
           <p:cNvSpPr txBox="1"/>
           <p:nvPr/>
         </p:nvSpPr>
         <p:spPr>
           <a:xfrm>
-            <a:off x="6260439" y="3749040"/>
-            <a:ext cx="2563291" cy="219456"/>
+            <a:off x="5532120" y="4828032"/>
+            <a:ext cx="6263640" cy="274320"/>
           </a:xfrm>
           <a:prstGeom prst="rect">
             <a:avLst/>
@@ -4274,40 +4306,42 @@
           </a:bodyPr>
           <a:lstStyle/>
           <a:p>
-            <a:r>
-              <a:rPr sz="1000" b="0" i="0">
-                <a:solidFill>
-                  <a:srgbClr val="64748B"/>
+            <a:pPr algn="l"/>
+            <a:r>
+              <a:rPr sz="950" b="1" i="1">
+                <a:solidFill>
+                  <a:srgbClr val="C4994E"/>
                 </a:solidFill>
                 <a:latin typeface="Calibri"/>
               </a:rPr>
-              <a:t>Run Critique + Model Council on the same question — see two answers compared side-by-side, pick the stronger.</a:t>
-            </a:r>
-          </a:p>
-        </p:txBody>
-      </p:sp>
-      <p:sp>
-        <p:nvSpPr>
-          <p:cNvPr id="33" name="Rectangle 32"/>
+              <a:t>Researcher</a:t>
+            </a:r>
+          </a:p>
+        </p:txBody>
+      </p:sp>
+      <p:sp>
+        <p:nvSpPr>
+          <p:cNvPr id="34" name="Rounded Rectangle 33"/>
           <p:cNvSpPr/>
           <p:nvPr/>
         </p:nvSpPr>
         <p:spPr>
           <a:xfrm>
-            <a:off x="9043187" y="2743200"/>
-            <a:ext cx="2782747" cy="1243584"/>
-          </a:xfrm>
-          <a:prstGeom prst="rect">
+            <a:off x="4572000" y="5257800"/>
+            <a:ext cx="7315200" cy="1078992"/>
+          </a:xfrm>
+          <a:prstGeom prst="roundRect">
             <a:avLst/>
           </a:prstGeom>
           <a:solidFill>
             <a:srgbClr val="F8FAFC"/>
           </a:solidFill>
-          <a:ln>
+          <a:ln w="6350">
             <a:solidFill>
-              <a:srgbClr val="D9DFE9"/>
+              <a:srgbClr val="D1D9E6"/>
             </a:solidFill>
           </a:ln>
+          <a:effectLst/>
         </p:spPr>
         <p:style>
           <a:lnRef idx="1">
@@ -4333,24 +4367,25 @@
       </p:sp>
       <p:sp>
         <p:nvSpPr>
-          <p:cNvPr id="34" name="Rectangle 33"/>
+          <p:cNvPr id="35" name="Rounded Rectangle 34"/>
           <p:cNvSpPr/>
           <p:nvPr/>
         </p:nvSpPr>
         <p:spPr>
           <a:xfrm>
-            <a:off x="9043187" y="2743200"/>
-            <a:ext cx="2782747" cy="365760"/>
-          </a:xfrm>
-          <a:prstGeom prst="rect">
+            <a:off x="4572000" y="5257800"/>
+            <a:ext cx="822960" cy="1078992"/>
+          </a:xfrm>
+          <a:prstGeom prst="roundRect">
             <a:avLst/>
           </a:prstGeom>
           <a:solidFill>
-            <a:srgbClr val="1E3A5F"/>
+            <a:srgbClr val="0F1F3D"/>
           </a:solidFill>
           <a:ln>
             <a:noFill/>
           </a:ln>
+          <a:effectLst/>
         </p:spPr>
         <p:style>
           <a:lnRef idx="1">
@@ -4376,14 +4411,14 @@
       </p:sp>
       <p:sp>
         <p:nvSpPr>
-          <p:cNvPr id="35" name="TextBox 34"/>
+          <p:cNvPr id="36" name="TextBox 35"/>
           <p:cNvSpPr txBox="1"/>
           <p:nvPr/>
         </p:nvSpPr>
         <p:spPr>
           <a:xfrm>
-            <a:off x="9134627" y="2788920"/>
-            <a:ext cx="2599867" cy="320040"/>
+            <a:off x="4572000" y="5257800"/>
+            <a:ext cx="822960" cy="1078992"/>
           </a:xfrm>
           <a:prstGeom prst="rect">
             <a:avLst/>
@@ -4391,33 +4426,34 @@
           <a:noFill/>
         </p:spPr>
         <p:txBody>
-          <a:bodyPr wrap="square" lIns="0" rIns="0" tIns="0" bIns="0">
+          <a:bodyPr wrap="square" lIns="0" rIns="0" tIns="0" bIns="0" anchor="ctr">
             <a:spAutoFit/>
           </a:bodyPr>
           <a:lstStyle/>
           <a:p>
-            <a:r>
-              <a:rPr sz="1100" b="1" i="0">
-                <a:solidFill>
-                  <a:srgbClr val="FFFFFF"/>
+            <a:pPr algn="ctr"/>
+            <a:r>
+              <a:rPr sz="2600" b="1" i="0">
+                <a:solidFill>
+                  <a:srgbClr val="C4994E"/>
                 </a:solidFill>
                 <a:latin typeface="Calibri"/>
               </a:rPr>
-              <a:t>04   PowerPoint Deck</a:t>
-            </a:r>
-          </a:p>
-        </p:txBody>
-      </p:sp>
-      <p:sp>
-        <p:nvSpPr>
-          <p:cNvPr id="36" name="TextBox 35"/>
+              <a:t>04</a:t>
+            </a:r>
+          </a:p>
+        </p:txBody>
+      </p:sp>
+      <p:sp>
+        <p:nvSpPr>
+          <p:cNvPr id="37" name="TextBox 36"/>
           <p:cNvSpPr txBox="1"/>
           <p:nvPr/>
         </p:nvSpPr>
         <p:spPr>
           <a:xfrm>
-            <a:off x="9152915" y="3182112"/>
-            <a:ext cx="2563291" cy="292608"/>
+            <a:off x="5532120" y="5367528"/>
+            <a:ext cx="4114800" cy="320040"/>
           </a:xfrm>
           <a:prstGeom prst="rect">
             <a:avLst/>
@@ -4430,28 +4466,29 @@
           </a:bodyPr>
           <a:lstStyle/>
           <a:p>
-            <a:r>
-              <a:rPr sz="1200" b="1" i="0">
-                <a:solidFill>
-                  <a:srgbClr val="1A202C"/>
+            <a:pPr algn="l"/>
+            <a:r>
+              <a:rPr sz="1100" b="1" i="0">
+                <a:solidFill>
+                  <a:srgbClr val="0F1F3D"/>
                 </a:solidFill>
                 <a:latin typeface="Calibri"/>
               </a:rPr>
-              <a:t>BCG / McKinsey-style draft</a:t>
-            </a:r>
-          </a:p>
-        </p:txBody>
-      </p:sp>
-      <p:sp>
-        <p:nvSpPr>
-          <p:cNvPr id="37" name="TextBox 36"/>
+              <a:t>STRATEGY DECK &amp; VISUALS</a:t>
+            </a:r>
+          </a:p>
+        </p:txBody>
+      </p:sp>
+      <p:sp>
+        <p:nvSpPr>
+          <p:cNvPr id="38" name="TextBox 37"/>
           <p:cNvSpPr txBox="1"/>
           <p:nvPr/>
         </p:nvSpPr>
         <p:spPr>
           <a:xfrm>
-            <a:off x="9152915" y="3493008"/>
-            <a:ext cx="2563291" cy="219456"/>
+            <a:off x="5532120" y="5641848"/>
+            <a:ext cx="6263640" cy="502920"/>
           </a:xfrm>
           <a:prstGeom prst="rect">
             <a:avLst/>
@@ -4464,28 +4501,29 @@
           </a:bodyPr>
           <a:lstStyle/>
           <a:p>
-            <a:r>
-              <a:rPr sz="950" b="0" i="1">
-                <a:solidFill>
-                  <a:srgbClr val="1E3A5F"/>
+            <a:pPr algn="l"/>
+            <a:r>
+              <a:rPr sz="1050" b="0" i="0">
+                <a:solidFill>
+                  <a:srgbClr val="1A202C"/>
                 </a:solidFill>
                 <a:latin typeface="Calibri"/>
               </a:rPr>
-              <a:t>PowerPoint Copilot</a:t>
-            </a:r>
-          </a:p>
-        </p:txBody>
-      </p:sp>
-      <p:sp>
-        <p:nvSpPr>
-          <p:cNvPr id="38" name="TextBox 37"/>
+              <a:t>BCG/McKinsey-style strategy deck on the corporate template, plus a Copilot-Create infographic. No design tool needed.</a:t>
+            </a:r>
+          </a:p>
+        </p:txBody>
+      </p:sp>
+      <p:sp>
+        <p:nvSpPr>
+          <p:cNvPr id="39" name="TextBox 38"/>
           <p:cNvSpPr txBox="1"/>
           <p:nvPr/>
         </p:nvSpPr>
         <p:spPr>
           <a:xfrm>
-            <a:off x="9152915" y="3749040"/>
-            <a:ext cx="2563291" cy="219456"/>
+            <a:off x="5532120" y="6016752"/>
+            <a:ext cx="6263640" cy="274320"/>
           </a:xfrm>
           <a:prstGeom prst="rect">
             <a:avLst/>
@@ -4498,40 +4536,40 @@
           </a:bodyPr>
           <a:lstStyle/>
           <a:p>
-            <a:r>
-              <a:rPr sz="1000" b="0" i="0">
-                <a:solidFill>
-                  <a:srgbClr val="64748B"/>
+            <a:pPr algn="l"/>
+            <a:r>
+              <a:rPr sz="950" b="1" i="1">
+                <a:solidFill>
+                  <a:srgbClr val="C4994E"/>
                 </a:solidFill>
                 <a:latin typeface="Calibri"/>
               </a:rPr>
-              <a:t>Copilot in PowerPoint drafts an 8-slide consultancy-style deck from the memo and KPI workbook.</a:t>
-            </a:r>
-          </a:p>
-        </p:txBody>
-      </p:sp>
-      <p:sp>
-        <p:nvSpPr>
-          <p:cNvPr id="39" name="Rectangle 38"/>
+              <a:t>PowerPoint · Create</a:t>
+            </a:r>
+          </a:p>
+        </p:txBody>
+      </p:sp>
+      <p:sp>
+        <p:nvSpPr>
+          <p:cNvPr id="40" name="Rectangle 39"/>
           <p:cNvSpPr/>
           <p:nvPr/>
         </p:nvSpPr>
         <p:spPr>
           <a:xfrm>
-            <a:off x="365760" y="4096512"/>
-            <a:ext cx="2782747" cy="1243584"/>
+            <a:off x="4572000" y="6355080"/>
+            <a:ext cx="7315200" cy="365760"/>
           </a:xfrm>
           <a:prstGeom prst="rect">
             <a:avLst/>
           </a:prstGeom>
           <a:solidFill>
-            <a:srgbClr val="F8FAFC"/>
+            <a:srgbClr val="C4994E"/>
           </a:solidFill>
           <a:ln>
-            <a:solidFill>
-              <a:srgbClr val="D9DFE9"/>
-            </a:solidFill>
+            <a:noFill/>
           </a:ln>
+          <a:effectLst/>
         </p:spPr>
         <p:style>
           <a:lnRef idx="1">
@@ -4557,57 +4595,14 @@
       </p:sp>
       <p:sp>
         <p:nvSpPr>
-          <p:cNvPr id="40" name="Rectangle 39"/>
-          <p:cNvSpPr/>
-          <p:nvPr/>
-        </p:nvSpPr>
-        <p:spPr>
-          <a:xfrm>
-            <a:off x="365760" y="4096512"/>
-            <a:ext cx="2782747" cy="365760"/>
-          </a:xfrm>
-          <a:prstGeom prst="rect">
-            <a:avLst/>
-          </a:prstGeom>
-          <a:solidFill>
-            <a:srgbClr val="8B2635"/>
-          </a:solidFill>
-          <a:ln>
-            <a:noFill/>
-          </a:ln>
-        </p:spPr>
-        <p:style>
-          <a:lnRef idx="1">
-            <a:schemeClr val="accent1"/>
-          </a:lnRef>
-          <a:fillRef idx="3">
-            <a:schemeClr val="accent1"/>
-          </a:fillRef>
-          <a:effectRef idx="2">
-            <a:schemeClr val="accent1"/>
-          </a:effectRef>
-          <a:fontRef idx="minor">
-            <a:schemeClr val="lt1"/>
-          </a:fontRef>
-        </p:style>
-        <p:txBody>
-          <a:bodyPr rtlCol="0" anchor="ctr"/>
-          <a:lstStyle/>
-          <a:p>
-            <a:pPr algn="ctr"/>
-          </a:p>
-        </p:txBody>
-      </p:sp>
-      <p:sp>
-        <p:nvSpPr>
           <p:cNvPr id="41" name="TextBox 40"/>
           <p:cNvSpPr txBox="1"/>
           <p:nvPr/>
         </p:nvSpPr>
         <p:spPr>
           <a:xfrm>
-            <a:off x="457200" y="4142232"/>
-            <a:ext cx="2599867" cy="320040"/>
+            <a:off x="4754880" y="6409944"/>
+            <a:ext cx="7040880" cy="274320"/>
           </a:xfrm>
           <a:prstGeom prst="rect">
             <a:avLst/>
@@ -4620,1574 +4615,15 @@
           </a:bodyPr>
           <a:lstStyle/>
           <a:p>
-            <a:r>
-              <a:rPr sz="1100" b="1" i="0">
-                <a:solidFill>
-                  <a:srgbClr val="FFFFFF"/>
+            <a:pPr algn="l"/>
+            <a:r>
+              <a:rPr sz="1000" b="1" i="0">
+                <a:solidFill>
+                  <a:srgbClr val="0F1F3D"/>
                 </a:solidFill>
                 <a:latin typeface="Calibri"/>
               </a:rPr>
-              <a:t>05   Visual Infographic</a:t>
-            </a:r>
-          </a:p>
-        </p:txBody>
-      </p:sp>
-      <p:sp>
-        <p:nvSpPr>
-          <p:cNvPr id="42" name="TextBox 41"/>
-          <p:cNvSpPr txBox="1"/>
-          <p:nvPr/>
-        </p:nvSpPr>
-        <p:spPr>
-          <a:xfrm>
-            <a:off x="475488" y="4535424"/>
-            <a:ext cx="2563291" cy="292608"/>
-          </a:xfrm>
-          <a:prstGeom prst="rect">
-            <a:avLst/>
-          </a:prstGeom>
-          <a:noFill/>
-        </p:spPr>
-        <p:txBody>
-          <a:bodyPr wrap="square" lIns="0" rIns="0" tIns="0" bIns="0">
-            <a:spAutoFit/>
-          </a:bodyPr>
-          <a:lstStyle/>
-          <a:p>
-            <a:r>
-              <a:rPr sz="1200" b="1" i="0">
-                <a:solidFill>
-                  <a:srgbClr val="1A202C"/>
-                </a:solidFill>
-                <a:latin typeface="Calibri"/>
-              </a:rPr>
-              <a:t>Branded one-page poster</a:t>
-            </a:r>
-          </a:p>
-        </p:txBody>
-      </p:sp>
-      <p:sp>
-        <p:nvSpPr>
-          <p:cNvPr id="43" name="TextBox 42"/>
-          <p:cNvSpPr txBox="1"/>
-          <p:nvPr/>
-        </p:nvSpPr>
-        <p:spPr>
-          <a:xfrm>
-            <a:off x="475488" y="4846320"/>
-            <a:ext cx="2563291" cy="219456"/>
-          </a:xfrm>
-          <a:prstGeom prst="rect">
-            <a:avLst/>
-          </a:prstGeom>
-          <a:noFill/>
-        </p:spPr>
-        <p:txBody>
-          <a:bodyPr wrap="square" lIns="0" rIns="0" tIns="0" bIns="0">
-            <a:spAutoFit/>
-          </a:bodyPr>
-          <a:lstStyle/>
-          <a:p>
-            <a:r>
-              <a:rPr sz="950" b="0" i="1">
-                <a:solidFill>
-                  <a:srgbClr val="8B2635"/>
-                </a:solidFill>
-                <a:latin typeface="Calibri"/>
-              </a:rPr>
-              <a:t>Copilot Create (Designer)</a:t>
-            </a:r>
-          </a:p>
-        </p:txBody>
-      </p:sp>
-      <p:sp>
-        <p:nvSpPr>
-          <p:cNvPr id="44" name="TextBox 43"/>
-          <p:cNvSpPr txBox="1"/>
-          <p:nvPr/>
-        </p:nvSpPr>
-        <p:spPr>
-          <a:xfrm>
-            <a:off x="475488" y="5102352"/>
-            <a:ext cx="2563291" cy="219456"/>
-          </a:xfrm>
-          <a:prstGeom prst="rect">
-            <a:avLst/>
-          </a:prstGeom>
-          <a:noFill/>
-        </p:spPr>
-        <p:txBody>
-          <a:bodyPr wrap="square" lIns="0" rIns="0" tIns="0" bIns="0">
-            <a:spAutoFit/>
-          </a:bodyPr>
-          <a:lstStyle/>
-          <a:p>
-            <a:r>
-              <a:rPr sz="1000" b="0" i="0">
-                <a:solidFill>
-                  <a:srgbClr val="64748B"/>
-                </a:solidFill>
-                <a:latin typeface="Calibri"/>
-              </a:rPr>
-              <a:t>Copilot Create generates a brand-aligned infographic poster from a single prompt — no design tool.</a:t>
-            </a:r>
-          </a:p>
-        </p:txBody>
-      </p:sp>
-      <p:sp>
-        <p:nvSpPr>
-          <p:cNvPr id="45" name="Rectangle 44"/>
-          <p:cNvSpPr/>
-          <p:nvPr/>
-        </p:nvSpPr>
-        <p:spPr>
-          <a:xfrm>
-            <a:off x="3258235" y="4096512"/>
-            <a:ext cx="2782747" cy="1243584"/>
-          </a:xfrm>
-          <a:prstGeom prst="rect">
-            <a:avLst/>
-          </a:prstGeom>
-          <a:solidFill>
-            <a:srgbClr val="F8FAFC"/>
-          </a:solidFill>
-          <a:ln>
-            <a:solidFill>
-              <a:srgbClr val="D9DFE9"/>
-            </a:solidFill>
-          </a:ln>
-        </p:spPr>
-        <p:style>
-          <a:lnRef idx="1">
-            <a:schemeClr val="accent1"/>
-          </a:lnRef>
-          <a:fillRef idx="3">
-            <a:schemeClr val="accent1"/>
-          </a:fillRef>
-          <a:effectRef idx="2">
-            <a:schemeClr val="accent1"/>
-          </a:effectRef>
-          <a:fontRef idx="minor">
-            <a:schemeClr val="lt1"/>
-          </a:fontRef>
-        </p:style>
-        <p:txBody>
-          <a:bodyPr rtlCol="0" anchor="ctr"/>
-          <a:lstStyle/>
-          <a:p>
-            <a:pPr algn="ctr"/>
-          </a:p>
-        </p:txBody>
-      </p:sp>
-      <p:sp>
-        <p:nvSpPr>
-          <p:cNvPr id="46" name="Rectangle 45"/>
-          <p:cNvSpPr/>
-          <p:nvPr/>
-        </p:nvSpPr>
-        <p:spPr>
-          <a:xfrm>
-            <a:off x="3258235" y="4096512"/>
-            <a:ext cx="2782747" cy="365760"/>
-          </a:xfrm>
-          <a:prstGeom prst="rect">
-            <a:avLst/>
-          </a:prstGeom>
-          <a:solidFill>
-            <a:srgbClr val="7C2D12"/>
-          </a:solidFill>
-          <a:ln>
-            <a:noFill/>
-          </a:ln>
-        </p:spPr>
-        <p:style>
-          <a:lnRef idx="1">
-            <a:schemeClr val="accent1"/>
-          </a:lnRef>
-          <a:fillRef idx="3">
-            <a:schemeClr val="accent1"/>
-          </a:fillRef>
-          <a:effectRef idx="2">
-            <a:schemeClr val="accent1"/>
-          </a:effectRef>
-          <a:fontRef idx="minor">
-            <a:schemeClr val="lt1"/>
-          </a:fontRef>
-        </p:style>
-        <p:txBody>
-          <a:bodyPr rtlCol="0" anchor="ctr"/>
-          <a:lstStyle/>
-          <a:p>
-            <a:pPr algn="ctr"/>
-          </a:p>
-        </p:txBody>
-      </p:sp>
-      <p:sp>
-        <p:nvSpPr>
-          <p:cNvPr id="47" name="TextBox 46"/>
-          <p:cNvSpPr txBox="1"/>
-          <p:nvPr/>
-        </p:nvSpPr>
-        <p:spPr>
-          <a:xfrm>
-            <a:off x="3349675" y="4142232"/>
-            <a:ext cx="2599867" cy="320040"/>
-          </a:xfrm>
-          <a:prstGeom prst="rect">
-            <a:avLst/>
-          </a:prstGeom>
-          <a:noFill/>
-        </p:spPr>
-        <p:txBody>
-          <a:bodyPr wrap="square" lIns="0" rIns="0" tIns="0" bIns="0">
-            <a:spAutoFit/>
-          </a:bodyPr>
-          <a:lstStyle/>
-          <a:p>
-            <a:r>
-              <a:rPr sz="1100" b="1" i="0">
-                <a:solidFill>
-                  <a:srgbClr val="FFFFFF"/>
-                </a:solidFill>
-                <a:latin typeface="Calibri"/>
-              </a:rPr>
-              <a:t>06   Teams Recap → Minutes</a:t>
-            </a:r>
-          </a:p>
-        </p:txBody>
-      </p:sp>
-      <p:sp>
-        <p:nvSpPr>
-          <p:cNvPr id="48" name="TextBox 47"/>
-          <p:cNvSpPr txBox="1"/>
-          <p:nvPr/>
-        </p:nvSpPr>
-        <p:spPr>
-          <a:xfrm>
-            <a:off x="3367963" y="4535424"/>
-            <a:ext cx="2563291" cy="292608"/>
-          </a:xfrm>
-          <a:prstGeom prst="rect">
-            <a:avLst/>
-          </a:prstGeom>
-          <a:noFill/>
-        </p:spPr>
-        <p:txBody>
-          <a:bodyPr wrap="square" lIns="0" rIns="0" tIns="0" bIns="0">
-            <a:spAutoFit/>
-          </a:bodyPr>
-          <a:lstStyle/>
-          <a:p>
-            <a:r>
-              <a:rPr sz="1200" b="1" i="0">
-                <a:solidFill>
-                  <a:srgbClr val="1A202C"/>
-                </a:solidFill>
-                <a:latin typeface="Calibri"/>
-              </a:rPr>
-              <a:t>Catch up on a missed meeting</a:t>
-            </a:r>
-          </a:p>
-        </p:txBody>
-      </p:sp>
-      <p:sp>
-        <p:nvSpPr>
-          <p:cNvPr id="49" name="TextBox 48"/>
-          <p:cNvSpPr txBox="1"/>
-          <p:nvPr/>
-        </p:nvSpPr>
-        <p:spPr>
-          <a:xfrm>
-            <a:off x="3367963" y="4846320"/>
-            <a:ext cx="2563291" cy="219456"/>
-          </a:xfrm>
-          <a:prstGeom prst="rect">
-            <a:avLst/>
-          </a:prstGeom>
-          <a:noFill/>
-        </p:spPr>
-        <p:txBody>
-          <a:bodyPr wrap="square" lIns="0" rIns="0" tIns="0" bIns="0">
-            <a:spAutoFit/>
-          </a:bodyPr>
-          <a:lstStyle/>
-          <a:p>
-            <a:r>
-              <a:rPr sz="950" b="0" i="1">
-                <a:solidFill>
-                  <a:srgbClr val="7C2D12"/>
-                </a:solidFill>
-                <a:latin typeface="Calibri"/>
-              </a:rPr>
-              <a:t>Teams · Word Copilot</a:t>
-            </a:r>
-          </a:p>
-        </p:txBody>
-      </p:sp>
-      <p:sp>
-        <p:nvSpPr>
-          <p:cNvPr id="50" name="TextBox 49"/>
-          <p:cNvSpPr txBox="1"/>
-          <p:nvPr/>
-        </p:nvSpPr>
-        <p:spPr>
-          <a:xfrm>
-            <a:off x="3367963" y="5102352"/>
-            <a:ext cx="2563291" cy="219456"/>
-          </a:xfrm>
-          <a:prstGeom prst="rect">
-            <a:avLst/>
-          </a:prstGeom>
-          <a:noFill/>
-        </p:spPr>
-        <p:txBody>
-          <a:bodyPr wrap="square" lIns="0" rIns="0" tIns="0" bIns="0">
-            <a:spAutoFit/>
-          </a:bodyPr>
-          <a:lstStyle/>
-          <a:p>
-            <a:r>
-              <a:rPr sz="1000" b="0" i="0">
-                <a:solidFill>
-                  <a:srgbClr val="64748B"/>
-                </a:solidFill>
-                <a:latin typeface="Calibri"/>
-              </a:rPr>
-              <a:t>Teams Recap summarises a missed meeting; Copilot in Word turns the transcript into formal minutes.</a:t>
-            </a:r>
-          </a:p>
-        </p:txBody>
-      </p:sp>
-      <p:sp>
-        <p:nvSpPr>
-          <p:cNvPr id="51" name="Rectangle 50"/>
-          <p:cNvSpPr/>
-          <p:nvPr/>
-        </p:nvSpPr>
-        <p:spPr>
-          <a:xfrm>
-            <a:off x="6150711" y="4096512"/>
-            <a:ext cx="2782747" cy="1243584"/>
-          </a:xfrm>
-          <a:prstGeom prst="rect">
-            <a:avLst/>
-          </a:prstGeom>
-          <a:solidFill>
-            <a:srgbClr val="F8FAFC"/>
-          </a:solidFill>
-          <a:ln>
-            <a:solidFill>
-              <a:srgbClr val="D9DFE9"/>
-            </a:solidFill>
-          </a:ln>
-        </p:spPr>
-        <p:style>
-          <a:lnRef idx="1">
-            <a:schemeClr val="accent1"/>
-          </a:lnRef>
-          <a:fillRef idx="3">
-            <a:schemeClr val="accent1"/>
-          </a:fillRef>
-          <a:effectRef idx="2">
-            <a:schemeClr val="accent1"/>
-          </a:effectRef>
-          <a:fontRef idx="minor">
-            <a:schemeClr val="lt1"/>
-          </a:fontRef>
-        </p:style>
-        <p:txBody>
-          <a:bodyPr rtlCol="0" anchor="ctr"/>
-          <a:lstStyle/>
-          <a:p>
-            <a:pPr algn="ctr"/>
-          </a:p>
-        </p:txBody>
-      </p:sp>
-      <p:sp>
-        <p:nvSpPr>
-          <p:cNvPr id="52" name="Rectangle 51"/>
-          <p:cNvSpPr/>
-          <p:nvPr/>
-        </p:nvSpPr>
-        <p:spPr>
-          <a:xfrm>
-            <a:off x="6150711" y="4096512"/>
-            <a:ext cx="2782747" cy="365760"/>
-          </a:xfrm>
-          <a:prstGeom prst="rect">
-            <a:avLst/>
-          </a:prstGeom>
-          <a:solidFill>
-            <a:srgbClr val="14532D"/>
-          </a:solidFill>
-          <a:ln>
-            <a:noFill/>
-          </a:ln>
-        </p:spPr>
-        <p:style>
-          <a:lnRef idx="1">
-            <a:schemeClr val="accent1"/>
-          </a:lnRef>
-          <a:fillRef idx="3">
-            <a:schemeClr val="accent1"/>
-          </a:fillRef>
-          <a:effectRef idx="2">
-            <a:schemeClr val="accent1"/>
-          </a:effectRef>
-          <a:fontRef idx="minor">
-            <a:schemeClr val="lt1"/>
-          </a:fontRef>
-        </p:style>
-        <p:txBody>
-          <a:bodyPr rtlCol="0" anchor="ctr"/>
-          <a:lstStyle/>
-          <a:p>
-            <a:pPr algn="ctr"/>
-          </a:p>
-        </p:txBody>
-      </p:sp>
-      <p:sp>
-        <p:nvSpPr>
-          <p:cNvPr id="53" name="TextBox 52"/>
-          <p:cNvSpPr txBox="1"/>
-          <p:nvPr/>
-        </p:nvSpPr>
-        <p:spPr>
-          <a:xfrm>
-            <a:off x="6242151" y="4142232"/>
-            <a:ext cx="2599867" cy="320040"/>
-          </a:xfrm>
-          <a:prstGeom prst="rect">
-            <a:avLst/>
-          </a:prstGeom>
-          <a:noFill/>
-        </p:spPr>
-        <p:txBody>
-          <a:bodyPr wrap="square" lIns="0" rIns="0" tIns="0" bIns="0">
-            <a:spAutoFit/>
-          </a:bodyPr>
-          <a:lstStyle/>
-          <a:p>
-            <a:r>
-              <a:rPr sz="1100" b="1" i="0">
-                <a:solidFill>
-                  <a:srgbClr val="FFFFFF"/>
-                </a:solidFill>
-                <a:latin typeface="Calibri"/>
-              </a:rPr>
-              <a:t>07   Excel Power Hour</a:t>
-            </a:r>
-          </a:p>
-        </p:txBody>
-      </p:sp>
-      <p:sp>
-        <p:nvSpPr>
-          <p:cNvPr id="54" name="TextBox 53"/>
-          <p:cNvSpPr txBox="1"/>
-          <p:nvPr/>
-        </p:nvSpPr>
-        <p:spPr>
-          <a:xfrm>
-            <a:off x="6260439" y="4535424"/>
-            <a:ext cx="2563291" cy="292608"/>
-          </a:xfrm>
-          <a:prstGeom prst="rect">
-            <a:avLst/>
-          </a:prstGeom>
-          <a:noFill/>
-        </p:spPr>
-        <p:txBody>
-          <a:bodyPr wrap="square" lIns="0" rIns="0" tIns="0" bIns="0">
-            <a:spAutoFit/>
-          </a:bodyPr>
-          <a:lstStyle/>
-          <a:p>
-            <a:r>
-              <a:rPr sz="1200" b="1" i="0">
-                <a:solidFill>
-                  <a:srgbClr val="1A202C"/>
-                </a:solidFill>
-                <a:latin typeface="Calibri"/>
-              </a:rPr>
-              <a:t>Chat · Edit · Plan</a:t>
-            </a:r>
-          </a:p>
-        </p:txBody>
-      </p:sp>
-      <p:sp>
-        <p:nvSpPr>
-          <p:cNvPr id="55" name="TextBox 54"/>
-          <p:cNvSpPr txBox="1"/>
-          <p:nvPr/>
-        </p:nvSpPr>
-        <p:spPr>
-          <a:xfrm>
-            <a:off x="6260439" y="4846320"/>
-            <a:ext cx="2563291" cy="219456"/>
-          </a:xfrm>
-          <a:prstGeom prst="rect">
-            <a:avLst/>
-          </a:prstGeom>
-          <a:noFill/>
-        </p:spPr>
-        <p:txBody>
-          <a:bodyPr wrap="square" lIns="0" rIns="0" tIns="0" bIns="0">
-            <a:spAutoFit/>
-          </a:bodyPr>
-          <a:lstStyle/>
-          <a:p>
-            <a:r>
-              <a:rPr sz="950" b="0" i="1">
-                <a:solidFill>
-                  <a:srgbClr val="14532D"/>
-                </a:solidFill>
-                <a:latin typeface="Calibri"/>
-              </a:rPr>
-              <a:t>Copilot in Excel</a:t>
-            </a:r>
-          </a:p>
-        </p:txBody>
-      </p:sp>
-      <p:sp>
-        <p:nvSpPr>
-          <p:cNvPr id="56" name="TextBox 55"/>
-          <p:cNvSpPr txBox="1"/>
-          <p:nvPr/>
-        </p:nvSpPr>
-        <p:spPr>
-          <a:xfrm>
-            <a:off x="6260439" y="5102352"/>
-            <a:ext cx="2563291" cy="219456"/>
-          </a:xfrm>
-          <a:prstGeom prst="rect">
-            <a:avLst/>
-          </a:prstGeom>
-          <a:noFill/>
-        </p:spPr>
-        <p:txBody>
-          <a:bodyPr wrap="square" lIns="0" rIns="0" tIns="0" bIns="0">
-            <a:spAutoFit/>
-          </a:bodyPr>
-          <a:lstStyle/>
-          <a:p>
-            <a:r>
-              <a:rPr sz="1000" b="0" i="0">
-                <a:solidFill>
-                  <a:srgbClr val="64748B"/>
-                </a:solidFill>
-                <a:latin typeface="Calibri"/>
-              </a:rPr>
-              <a:t>Insights from your KPI workbook, surgical Edit changes, and multi-step Plan — all on one file.</a:t>
-            </a:r>
-          </a:p>
-        </p:txBody>
-      </p:sp>
-      <p:sp>
-        <p:nvSpPr>
-          <p:cNvPr id="57" name="Rectangle 56"/>
-          <p:cNvSpPr/>
-          <p:nvPr/>
-        </p:nvSpPr>
-        <p:spPr>
-          <a:xfrm>
-            <a:off x="9043187" y="4096512"/>
-            <a:ext cx="2782747" cy="1243584"/>
-          </a:xfrm>
-          <a:prstGeom prst="rect">
-            <a:avLst/>
-          </a:prstGeom>
-          <a:solidFill>
-            <a:srgbClr val="F8FAFC"/>
-          </a:solidFill>
-          <a:ln>
-            <a:solidFill>
-              <a:srgbClr val="D9DFE9"/>
-            </a:solidFill>
-          </a:ln>
-        </p:spPr>
-        <p:style>
-          <a:lnRef idx="1">
-            <a:schemeClr val="accent1"/>
-          </a:lnRef>
-          <a:fillRef idx="3">
-            <a:schemeClr val="accent1"/>
-          </a:fillRef>
-          <a:effectRef idx="2">
-            <a:schemeClr val="accent1"/>
-          </a:effectRef>
-          <a:fontRef idx="minor">
-            <a:schemeClr val="lt1"/>
-          </a:fontRef>
-        </p:style>
-        <p:txBody>
-          <a:bodyPr rtlCol="0" anchor="ctr"/>
-          <a:lstStyle/>
-          <a:p>
-            <a:pPr algn="ctr"/>
-          </a:p>
-        </p:txBody>
-      </p:sp>
-      <p:sp>
-        <p:nvSpPr>
-          <p:cNvPr id="58" name="Rectangle 57"/>
-          <p:cNvSpPr/>
-          <p:nvPr/>
-        </p:nvSpPr>
-        <p:spPr>
-          <a:xfrm>
-            <a:off x="9043187" y="4096512"/>
-            <a:ext cx="2782747" cy="365760"/>
-          </a:xfrm>
-          <a:prstGeom prst="rect">
-            <a:avLst/>
-          </a:prstGeom>
-          <a:solidFill>
-            <a:srgbClr val="365314"/>
-          </a:solidFill>
-          <a:ln>
-            <a:noFill/>
-          </a:ln>
-        </p:spPr>
-        <p:style>
-          <a:lnRef idx="1">
-            <a:schemeClr val="accent1"/>
-          </a:lnRef>
-          <a:fillRef idx="3">
-            <a:schemeClr val="accent1"/>
-          </a:fillRef>
-          <a:effectRef idx="2">
-            <a:schemeClr val="accent1"/>
-          </a:effectRef>
-          <a:fontRef idx="minor">
-            <a:schemeClr val="lt1"/>
-          </a:fontRef>
-        </p:style>
-        <p:txBody>
-          <a:bodyPr rtlCol="0" anchor="ctr"/>
-          <a:lstStyle/>
-          <a:p>
-            <a:pPr algn="ctr"/>
-          </a:p>
-        </p:txBody>
-      </p:sp>
-      <p:sp>
-        <p:nvSpPr>
-          <p:cNvPr id="59" name="TextBox 58"/>
-          <p:cNvSpPr txBox="1"/>
-          <p:nvPr/>
-        </p:nvSpPr>
-        <p:spPr>
-          <a:xfrm>
-            <a:off x="9134627" y="4142232"/>
-            <a:ext cx="2599867" cy="320040"/>
-          </a:xfrm>
-          <a:prstGeom prst="rect">
-            <a:avLst/>
-          </a:prstGeom>
-          <a:noFill/>
-        </p:spPr>
-        <p:txBody>
-          <a:bodyPr wrap="square" lIns="0" rIns="0" tIns="0" bIns="0">
-            <a:spAutoFit/>
-          </a:bodyPr>
-          <a:lstStyle/>
-          <a:p>
-            <a:r>
-              <a:rPr sz="1100" b="1" i="0">
-                <a:solidFill>
-                  <a:srgbClr val="FFFFFF"/>
-                </a:solidFill>
-                <a:latin typeface="Calibri"/>
-              </a:rPr>
-              <a:t>08   Analyst Agent</a:t>
-            </a:r>
-          </a:p>
-        </p:txBody>
-      </p:sp>
-      <p:sp>
-        <p:nvSpPr>
-          <p:cNvPr id="60" name="TextBox 59"/>
-          <p:cNvSpPr txBox="1"/>
-          <p:nvPr/>
-        </p:nvSpPr>
-        <p:spPr>
-          <a:xfrm>
-            <a:off x="9152915" y="4535424"/>
-            <a:ext cx="2563291" cy="292608"/>
-          </a:xfrm>
-          <a:prstGeom prst="rect">
-            <a:avLst/>
-          </a:prstGeom>
-          <a:noFill/>
-        </p:spPr>
-        <p:txBody>
-          <a:bodyPr wrap="square" lIns="0" rIns="0" tIns="0" bIns="0">
-            <a:spAutoFit/>
-          </a:bodyPr>
-          <a:lstStyle/>
-          <a:p>
-            <a:r>
-              <a:rPr sz="1200" b="1" i="0">
-                <a:solidFill>
-                  <a:srgbClr val="1A202C"/>
-                </a:solidFill>
-                <a:latin typeface="Calibri"/>
-              </a:rPr>
-              <a:t>Multiple perspectives, same data</a:t>
-            </a:r>
-          </a:p>
-        </p:txBody>
-      </p:sp>
-      <p:sp>
-        <p:nvSpPr>
-          <p:cNvPr id="61" name="TextBox 60"/>
-          <p:cNvSpPr txBox="1"/>
-          <p:nvPr/>
-        </p:nvSpPr>
-        <p:spPr>
-          <a:xfrm>
-            <a:off x="9152915" y="4846320"/>
-            <a:ext cx="2563291" cy="219456"/>
-          </a:xfrm>
-          <a:prstGeom prst="rect">
-            <a:avLst/>
-          </a:prstGeom>
-          <a:noFill/>
-        </p:spPr>
-        <p:txBody>
-          <a:bodyPr wrap="square" lIns="0" rIns="0" tIns="0" bIns="0">
-            <a:spAutoFit/>
-          </a:bodyPr>
-          <a:lstStyle/>
-          <a:p>
-            <a:r>
-              <a:rPr sz="950" b="0" i="1">
-                <a:solidFill>
-                  <a:srgbClr val="365314"/>
-                </a:solidFill>
-                <a:latin typeface="Calibri"/>
-              </a:rPr>
-              <a:t>Analyst Agent</a:t>
-            </a:r>
-          </a:p>
-        </p:txBody>
-      </p:sp>
-      <p:sp>
-        <p:nvSpPr>
-          <p:cNvPr id="62" name="TextBox 61"/>
-          <p:cNvSpPr txBox="1"/>
-          <p:nvPr/>
-        </p:nvSpPr>
-        <p:spPr>
-          <a:xfrm>
-            <a:off x="9152915" y="5102352"/>
-            <a:ext cx="2563291" cy="219456"/>
-          </a:xfrm>
-          <a:prstGeom prst="rect">
-            <a:avLst/>
-          </a:prstGeom>
-          <a:noFill/>
-        </p:spPr>
-        <p:txBody>
-          <a:bodyPr wrap="square" lIns="0" rIns="0" tIns="0" bIns="0">
-            <a:spAutoFit/>
-          </a:bodyPr>
-          <a:lstStyle/>
-          <a:p>
-            <a:r>
-              <a:rPr sz="1000" b="0" i="0">
-                <a:solidFill>
-                  <a:srgbClr val="64748B"/>
-                </a:solidFill>
-                <a:latin typeface="Calibri"/>
-              </a:rPr>
-              <a:t>Reasons across the data as a CFO, COO and Strategy Director — three angles, one dataset.</a:t>
-            </a:r>
-          </a:p>
-        </p:txBody>
-      </p:sp>
-      <p:sp>
-        <p:nvSpPr>
-          <p:cNvPr id="63" name="Rectangle 62"/>
-          <p:cNvSpPr/>
-          <p:nvPr/>
-        </p:nvSpPr>
-        <p:spPr>
-          <a:xfrm>
-            <a:off x="365760" y="5449824"/>
-            <a:ext cx="2782747" cy="1243584"/>
-          </a:xfrm>
-          <a:prstGeom prst="rect">
-            <a:avLst/>
-          </a:prstGeom>
-          <a:solidFill>
-            <a:srgbClr val="F8FAFC"/>
-          </a:solidFill>
-          <a:ln>
-            <a:solidFill>
-              <a:srgbClr val="D9DFE9"/>
-            </a:solidFill>
-          </a:ln>
-        </p:spPr>
-        <p:style>
-          <a:lnRef idx="1">
-            <a:schemeClr val="accent1"/>
-          </a:lnRef>
-          <a:fillRef idx="3">
-            <a:schemeClr val="accent1"/>
-          </a:fillRef>
-          <a:effectRef idx="2">
-            <a:schemeClr val="accent1"/>
-          </a:effectRef>
-          <a:fontRef idx="minor">
-            <a:schemeClr val="lt1"/>
-          </a:fontRef>
-        </p:style>
-        <p:txBody>
-          <a:bodyPr rtlCol="0" anchor="ctr"/>
-          <a:lstStyle/>
-          <a:p>
-            <a:pPr algn="ctr"/>
-          </a:p>
-        </p:txBody>
-      </p:sp>
-      <p:sp>
-        <p:nvSpPr>
-          <p:cNvPr id="64" name="Rectangle 63"/>
-          <p:cNvSpPr/>
-          <p:nvPr/>
-        </p:nvSpPr>
-        <p:spPr>
-          <a:xfrm>
-            <a:off x="365760" y="5449824"/>
-            <a:ext cx="2782747" cy="365760"/>
-          </a:xfrm>
-          <a:prstGeom prst="rect">
-            <a:avLst/>
-          </a:prstGeom>
-          <a:solidFill>
-            <a:srgbClr val="4C1D95"/>
-          </a:solidFill>
-          <a:ln>
-            <a:noFill/>
-          </a:ln>
-        </p:spPr>
-        <p:style>
-          <a:lnRef idx="1">
-            <a:schemeClr val="accent1"/>
-          </a:lnRef>
-          <a:fillRef idx="3">
-            <a:schemeClr val="accent1"/>
-          </a:fillRef>
-          <a:effectRef idx="2">
-            <a:schemeClr val="accent1"/>
-          </a:effectRef>
-          <a:fontRef idx="minor">
-            <a:schemeClr val="lt1"/>
-          </a:fontRef>
-        </p:style>
-        <p:txBody>
-          <a:bodyPr rtlCol="0" anchor="ctr"/>
-          <a:lstStyle/>
-          <a:p>
-            <a:pPr algn="ctr"/>
-          </a:p>
-        </p:txBody>
-      </p:sp>
-      <p:sp>
-        <p:nvSpPr>
-          <p:cNvPr id="65" name="TextBox 64"/>
-          <p:cNvSpPr txBox="1"/>
-          <p:nvPr/>
-        </p:nvSpPr>
-        <p:spPr>
-          <a:xfrm>
-            <a:off x="457200" y="5495544"/>
-            <a:ext cx="2599867" cy="320040"/>
-          </a:xfrm>
-          <a:prstGeom prst="rect">
-            <a:avLst/>
-          </a:prstGeom>
-          <a:noFill/>
-        </p:spPr>
-        <p:txBody>
-          <a:bodyPr wrap="square" lIns="0" rIns="0" tIns="0" bIns="0">
-            <a:spAutoFit/>
-          </a:bodyPr>
-          <a:lstStyle/>
-          <a:p>
-            <a:r>
-              <a:rPr sz="1100" b="1" i="0">
-                <a:solidFill>
-                  <a:srgbClr val="FFFFFF"/>
-                </a:solidFill>
-                <a:latin typeface="Calibri"/>
-              </a:rPr>
-              <a:t>09   Personalised Cascade</a:t>
-            </a:r>
-          </a:p>
-        </p:txBody>
-      </p:sp>
-      <p:sp>
-        <p:nvSpPr>
-          <p:cNvPr id="66" name="TextBox 65"/>
-          <p:cNvSpPr txBox="1"/>
-          <p:nvPr/>
-        </p:nvSpPr>
-        <p:spPr>
-          <a:xfrm>
-            <a:off x="475488" y="5888736"/>
-            <a:ext cx="2563291" cy="292608"/>
-          </a:xfrm>
-          <a:prstGeom prst="rect">
-            <a:avLst/>
-          </a:prstGeom>
-          <a:noFill/>
-        </p:spPr>
-        <p:txBody>
-          <a:bodyPr wrap="square" lIns="0" rIns="0" tIns="0" bIns="0">
-            <a:spAutoFit/>
-          </a:bodyPr>
-          <a:lstStyle/>
-          <a:p>
-            <a:r>
-              <a:rPr sz="1200" b="1" i="0">
-                <a:solidFill>
-                  <a:srgbClr val="1A202C"/>
-                </a:solidFill>
-                <a:latin typeface="Calibri"/>
-              </a:rPr>
-              <a:t>14 letters, one prompt</a:t>
-            </a:r>
-          </a:p>
-        </p:txBody>
-      </p:sp>
-      <p:sp>
-        <p:nvSpPr>
-          <p:cNvPr id="67" name="TextBox 66"/>
-          <p:cNvSpPr txBox="1"/>
-          <p:nvPr/>
-        </p:nvSpPr>
-        <p:spPr>
-          <a:xfrm>
-            <a:off x="475488" y="6199632"/>
-            <a:ext cx="2563291" cy="219456"/>
-          </a:xfrm>
-          <a:prstGeom prst="rect">
-            <a:avLst/>
-          </a:prstGeom>
-          <a:noFill/>
-        </p:spPr>
-        <p:txBody>
-          <a:bodyPr wrap="square" lIns="0" rIns="0" tIns="0" bIns="0">
-            <a:spAutoFit/>
-          </a:bodyPr>
-          <a:lstStyle/>
-          <a:p>
-            <a:r>
-              <a:rPr sz="950" b="0" i="1">
-                <a:solidFill>
-                  <a:srgbClr val="4C1D95"/>
-                </a:solidFill>
-                <a:latin typeface="Calibri"/>
-              </a:rPr>
-              <a:t>Cowork · Outlook drafts</a:t>
-            </a:r>
-          </a:p>
-        </p:txBody>
-      </p:sp>
-      <p:sp>
-        <p:nvSpPr>
-          <p:cNvPr id="68" name="TextBox 67"/>
-          <p:cNvSpPr txBox="1"/>
-          <p:nvPr/>
-        </p:nvSpPr>
-        <p:spPr>
-          <a:xfrm>
-            <a:off x="475488" y="6455664"/>
-            <a:ext cx="2563291" cy="219456"/>
-          </a:xfrm>
-          <a:prstGeom prst="rect">
-            <a:avLst/>
-          </a:prstGeom>
-          <a:noFill/>
-        </p:spPr>
-        <p:txBody>
-          <a:bodyPr wrap="square" lIns="0" rIns="0" tIns="0" bIns="0">
-            <a:spAutoFit/>
-          </a:bodyPr>
-          <a:lstStyle/>
-          <a:p>
-            <a:r>
-              <a:rPr sz="1000" b="0" i="0">
-                <a:solidFill>
-                  <a:srgbClr val="64748B"/>
-                </a:solidFill>
-                <a:latin typeface="Calibri"/>
-              </a:rPr>
-              <a:t>One Cowork prompt produces 14 personalised letters from the GM, each tuned to that person's data.</a:t>
-            </a:r>
-          </a:p>
-        </p:txBody>
-      </p:sp>
-      <p:sp>
-        <p:nvSpPr>
-          <p:cNvPr id="69" name="Rectangle 68"/>
-          <p:cNvSpPr/>
-          <p:nvPr/>
-        </p:nvSpPr>
-        <p:spPr>
-          <a:xfrm>
-            <a:off x="3258235" y="5449824"/>
-            <a:ext cx="2782747" cy="1243584"/>
-          </a:xfrm>
-          <a:prstGeom prst="rect">
-            <a:avLst/>
-          </a:prstGeom>
-          <a:solidFill>
-            <a:srgbClr val="F8FAFC"/>
-          </a:solidFill>
-          <a:ln>
-            <a:solidFill>
-              <a:srgbClr val="D9DFE9"/>
-            </a:solidFill>
-          </a:ln>
-        </p:spPr>
-        <p:style>
-          <a:lnRef idx="1">
-            <a:schemeClr val="accent1"/>
-          </a:lnRef>
-          <a:fillRef idx="3">
-            <a:schemeClr val="accent1"/>
-          </a:fillRef>
-          <a:effectRef idx="2">
-            <a:schemeClr val="accent1"/>
-          </a:effectRef>
-          <a:fontRef idx="minor">
-            <a:schemeClr val="lt1"/>
-          </a:fontRef>
-        </p:style>
-        <p:txBody>
-          <a:bodyPr rtlCol="0" anchor="ctr"/>
-          <a:lstStyle/>
-          <a:p>
-            <a:pPr algn="ctr"/>
-          </a:p>
-        </p:txBody>
-      </p:sp>
-      <p:sp>
-        <p:nvSpPr>
-          <p:cNvPr id="70" name="Rectangle 69"/>
-          <p:cNvSpPr/>
-          <p:nvPr/>
-        </p:nvSpPr>
-        <p:spPr>
-          <a:xfrm>
-            <a:off x="3258235" y="5449824"/>
-            <a:ext cx="2782747" cy="365760"/>
-          </a:xfrm>
-          <a:prstGeom prst="rect">
-            <a:avLst/>
-          </a:prstGeom>
-          <a:solidFill>
-            <a:srgbClr val="5B21B6"/>
-          </a:solidFill>
-          <a:ln>
-            <a:noFill/>
-          </a:ln>
-        </p:spPr>
-        <p:style>
-          <a:lnRef idx="1">
-            <a:schemeClr val="accent1"/>
-          </a:lnRef>
-          <a:fillRef idx="3">
-            <a:schemeClr val="accent1"/>
-          </a:fillRef>
-          <a:effectRef idx="2">
-            <a:schemeClr val="accent1"/>
-          </a:effectRef>
-          <a:fontRef idx="minor">
-            <a:schemeClr val="lt1"/>
-          </a:fontRef>
-        </p:style>
-        <p:txBody>
-          <a:bodyPr rtlCol="0" anchor="ctr"/>
-          <a:lstStyle/>
-          <a:p>
-            <a:pPr algn="ctr"/>
-          </a:p>
-        </p:txBody>
-      </p:sp>
-      <p:sp>
-        <p:nvSpPr>
-          <p:cNvPr id="71" name="TextBox 70"/>
-          <p:cNvSpPr txBox="1"/>
-          <p:nvPr/>
-        </p:nvSpPr>
-        <p:spPr>
-          <a:xfrm>
-            <a:off x="3349675" y="5495544"/>
-            <a:ext cx="2599867" cy="320040"/>
-          </a:xfrm>
-          <a:prstGeom prst="rect">
-            <a:avLst/>
-          </a:prstGeom>
-          <a:noFill/>
-        </p:spPr>
-        <p:txBody>
-          <a:bodyPr wrap="square" lIns="0" rIns="0" tIns="0" bIns="0">
-            <a:spAutoFit/>
-          </a:bodyPr>
-          <a:lstStyle/>
-          <a:p>
-            <a:r>
-              <a:rPr sz="1100" b="1" i="0">
-                <a:solidFill>
-                  <a:srgbClr val="FFFFFF"/>
-                </a:solidFill>
-                <a:latin typeface="Calibri"/>
-              </a:rPr>
-              <a:t>10   CV Screening</a:t>
-            </a:r>
-          </a:p>
-        </p:txBody>
-      </p:sp>
-      <p:sp>
-        <p:nvSpPr>
-          <p:cNvPr id="72" name="TextBox 71"/>
-          <p:cNvSpPr txBox="1"/>
-          <p:nvPr/>
-        </p:nvSpPr>
-        <p:spPr>
-          <a:xfrm>
-            <a:off x="3367963" y="5888736"/>
-            <a:ext cx="2563291" cy="292608"/>
-          </a:xfrm>
-          <a:prstGeom prst="rect">
-            <a:avLst/>
-          </a:prstGeom>
-          <a:noFill/>
-        </p:spPr>
-        <p:txBody>
-          <a:bodyPr wrap="square" lIns="0" rIns="0" tIns="0" bIns="0">
-            <a:spAutoFit/>
-          </a:bodyPr>
-          <a:lstStyle/>
-          <a:p>
-            <a:r>
-              <a:rPr sz="1200" b="1" i="0">
-                <a:solidFill>
-                  <a:srgbClr val="1A202C"/>
-                </a:solidFill>
-                <a:latin typeface="Calibri"/>
-              </a:rPr>
-              <a:t>12 CVs from SharePoint, ranked</a:t>
-            </a:r>
-          </a:p>
-        </p:txBody>
-      </p:sp>
-      <p:sp>
-        <p:nvSpPr>
-          <p:cNvPr id="73" name="TextBox 72"/>
-          <p:cNvSpPr txBox="1"/>
-          <p:nvPr/>
-        </p:nvSpPr>
-        <p:spPr>
-          <a:xfrm>
-            <a:off x="3367963" y="6199632"/>
-            <a:ext cx="2563291" cy="219456"/>
-          </a:xfrm>
-          <a:prstGeom prst="rect">
-            <a:avLst/>
-          </a:prstGeom>
-          <a:noFill/>
-        </p:spPr>
-        <p:txBody>
-          <a:bodyPr wrap="square" lIns="0" rIns="0" tIns="0" bIns="0">
-            <a:spAutoFit/>
-          </a:bodyPr>
-          <a:lstStyle/>
-          <a:p>
-            <a:r>
-              <a:rPr sz="950" b="0" i="1">
-                <a:solidFill>
-                  <a:srgbClr val="5B21B6"/>
-                </a:solidFill>
-                <a:latin typeface="Calibri"/>
-              </a:rPr>
-              <a:t>Cowork · SharePoint</a:t>
-            </a:r>
-          </a:p>
-        </p:txBody>
-      </p:sp>
-      <p:sp>
-        <p:nvSpPr>
-          <p:cNvPr id="74" name="TextBox 73"/>
-          <p:cNvSpPr txBox="1"/>
-          <p:nvPr/>
-        </p:nvSpPr>
-        <p:spPr>
-          <a:xfrm>
-            <a:off x="3367963" y="6455664"/>
-            <a:ext cx="2563291" cy="219456"/>
-          </a:xfrm>
-          <a:prstGeom prst="rect">
-            <a:avLst/>
-          </a:prstGeom>
-          <a:noFill/>
-        </p:spPr>
-        <p:txBody>
-          <a:bodyPr wrap="square" lIns="0" rIns="0" tIns="0" bIns="0">
-            <a:spAutoFit/>
-          </a:bodyPr>
-          <a:lstStyle/>
-          <a:p>
-            <a:r>
-              <a:rPr sz="1000" b="0" i="0">
-                <a:solidFill>
-                  <a:srgbClr val="64748B"/>
-                </a:solidFill>
-                <a:latin typeface="Calibri"/>
-              </a:rPr>
-              <a:t>Point Cowork at a SharePoint folder of 12 CVs and get a ranked shortlist with strengths and gaps.</a:t>
-            </a:r>
-          </a:p>
-        </p:txBody>
-      </p:sp>
-      <p:sp>
-        <p:nvSpPr>
-          <p:cNvPr id="75" name="Rectangle 74"/>
-          <p:cNvSpPr/>
-          <p:nvPr/>
-        </p:nvSpPr>
-        <p:spPr>
-          <a:xfrm>
-            <a:off x="6150711" y="5449824"/>
-            <a:ext cx="2782747" cy="1243584"/>
-          </a:xfrm>
-          <a:prstGeom prst="rect">
-            <a:avLst/>
-          </a:prstGeom>
-          <a:solidFill>
-            <a:srgbClr val="F8FAFC"/>
-          </a:solidFill>
-          <a:ln>
-            <a:solidFill>
-              <a:srgbClr val="D9DFE9"/>
-            </a:solidFill>
-          </a:ln>
-        </p:spPr>
-        <p:style>
-          <a:lnRef idx="1">
-            <a:schemeClr val="accent1"/>
-          </a:lnRef>
-          <a:fillRef idx="3">
-            <a:schemeClr val="accent1"/>
-          </a:fillRef>
-          <a:effectRef idx="2">
-            <a:schemeClr val="accent1"/>
-          </a:effectRef>
-          <a:fontRef idx="minor">
-            <a:schemeClr val="lt1"/>
-          </a:fontRef>
-        </p:style>
-        <p:txBody>
-          <a:bodyPr rtlCol="0" anchor="ctr"/>
-          <a:lstStyle/>
-          <a:p>
-            <a:pPr algn="ctr"/>
-          </a:p>
-        </p:txBody>
-      </p:sp>
-      <p:sp>
-        <p:nvSpPr>
-          <p:cNvPr id="76" name="Rectangle 75"/>
-          <p:cNvSpPr/>
-          <p:nvPr/>
-        </p:nvSpPr>
-        <p:spPr>
-          <a:xfrm>
-            <a:off x="6150711" y="5449824"/>
-            <a:ext cx="2782747" cy="365760"/>
-          </a:xfrm>
-          <a:prstGeom prst="rect">
-            <a:avLst/>
-          </a:prstGeom>
-          <a:solidFill>
-            <a:srgbClr val="475569"/>
-          </a:solidFill>
-          <a:ln>
-            <a:noFill/>
-          </a:ln>
-        </p:spPr>
-        <p:style>
-          <a:lnRef idx="1">
-            <a:schemeClr val="accent1"/>
-          </a:lnRef>
-          <a:fillRef idx="3">
-            <a:schemeClr val="accent1"/>
-          </a:fillRef>
-          <a:effectRef idx="2">
-            <a:schemeClr val="accent1"/>
-          </a:effectRef>
-          <a:fontRef idx="minor">
-            <a:schemeClr val="lt1"/>
-          </a:fontRef>
-        </p:style>
-        <p:txBody>
-          <a:bodyPr rtlCol="0" anchor="ctr"/>
-          <a:lstStyle/>
-          <a:p>
-            <a:pPr algn="ctr"/>
-          </a:p>
-        </p:txBody>
-      </p:sp>
-      <p:sp>
-        <p:nvSpPr>
-          <p:cNvPr id="77" name="TextBox 76"/>
-          <p:cNvSpPr txBox="1"/>
-          <p:nvPr/>
-        </p:nvSpPr>
-        <p:spPr>
-          <a:xfrm>
-            <a:off x="6242151" y="5495544"/>
-            <a:ext cx="2599867" cy="320040"/>
-          </a:xfrm>
-          <a:prstGeom prst="rect">
-            <a:avLst/>
-          </a:prstGeom>
-          <a:noFill/>
-        </p:spPr>
-        <p:txBody>
-          <a:bodyPr wrap="square" lIns="0" rIns="0" tIns="0" bIns="0">
-            <a:spAutoFit/>
-          </a:bodyPr>
-          <a:lstStyle/>
-          <a:p>
-            <a:r>
-              <a:rPr sz="1100" b="1" i="0">
-                <a:solidFill>
-                  <a:srgbClr val="FFFFFF"/>
-                </a:solidFill>
-                <a:latin typeface="Calibri"/>
-              </a:rPr>
-              <a:t>＋   Extras + Power Move</a:t>
-            </a:r>
-          </a:p>
-        </p:txBody>
-      </p:sp>
-      <p:sp>
-        <p:nvSpPr>
-          <p:cNvPr id="78" name="TextBox 77"/>
-          <p:cNvSpPr txBox="1"/>
-          <p:nvPr/>
-        </p:nvSpPr>
-        <p:spPr>
-          <a:xfrm>
-            <a:off x="6260439" y="5888736"/>
-            <a:ext cx="2563291" cy="292608"/>
-          </a:xfrm>
-          <a:prstGeom prst="rect">
-            <a:avLst/>
-          </a:prstGeom>
-          <a:noFill/>
-        </p:spPr>
-        <p:txBody>
-          <a:bodyPr wrap="square" lIns="0" rIns="0" tIns="0" bIns="0">
-            <a:spAutoFit/>
-          </a:bodyPr>
-          <a:lstStyle/>
-          <a:p>
-            <a:r>
-              <a:rPr sz="1200" b="1" i="0">
-                <a:solidFill>
-                  <a:srgbClr val="1A202C"/>
-                </a:solidFill>
-                <a:latin typeface="Calibri"/>
-              </a:rPr>
-              <a:t>Outlook · Word · industry use</a:t>
-            </a:r>
-          </a:p>
-        </p:txBody>
-      </p:sp>
-      <p:sp>
-        <p:nvSpPr>
-          <p:cNvPr id="79" name="TextBox 78"/>
-          <p:cNvSpPr txBox="1"/>
-          <p:nvPr/>
-        </p:nvSpPr>
-        <p:spPr>
-          <a:xfrm>
-            <a:off x="6260439" y="6199632"/>
-            <a:ext cx="2563291" cy="219456"/>
-          </a:xfrm>
-          <a:prstGeom prst="rect">
-            <a:avLst/>
-          </a:prstGeom>
-          <a:noFill/>
-        </p:spPr>
-        <p:txBody>
-          <a:bodyPr wrap="square" lIns="0" rIns="0" tIns="0" bIns="0">
-            <a:spAutoFit/>
-          </a:bodyPr>
-          <a:lstStyle/>
-          <a:p>
-            <a:r>
-              <a:rPr sz="950" b="0" i="1">
-                <a:solidFill>
-                  <a:srgbClr val="475569"/>
-                </a:solidFill>
-                <a:latin typeface="Calibri"/>
-              </a:rPr>
-              <a:t>If time allows</a:t>
-            </a:r>
-          </a:p>
-        </p:txBody>
-      </p:sp>
-      <p:sp>
-        <p:nvSpPr>
-          <p:cNvPr id="80" name="TextBox 79"/>
-          <p:cNvSpPr txBox="1"/>
-          <p:nvPr/>
-        </p:nvSpPr>
-        <p:spPr>
-          <a:xfrm>
-            <a:off x="6260439" y="6455664"/>
-            <a:ext cx="2563291" cy="219456"/>
-          </a:xfrm>
-          <a:prstGeom prst="rect">
-            <a:avLst/>
-          </a:prstGeom>
-          <a:noFill/>
-        </p:spPr>
-        <p:txBody>
-          <a:bodyPr wrap="square" lIns="0" rIns="0" tIns="0" bIns="0">
-            <a:spAutoFit/>
-          </a:bodyPr>
-          <a:lstStyle/>
-          <a:p>
-            <a:r>
-              <a:rPr sz="1000" b="0" i="0">
-                <a:solidFill>
-                  <a:srgbClr val="64748B"/>
-                </a:solidFill>
-                <a:latin typeface="Calibri"/>
-              </a:rPr>
-              <a:t>Lightning round: real Outlook thread catch-up, executive reply draft, long-doc Q&amp;A, industry power move.</a:t>
-            </a:r>
-          </a:p>
-        </p:txBody>
-      </p:sp>
-      <p:sp>
-        <p:nvSpPr>
-          <p:cNvPr id="81" name="Rectangle 80"/>
-          <p:cNvSpPr/>
-          <p:nvPr/>
-        </p:nvSpPr>
-        <p:spPr>
-          <a:xfrm>
-            <a:off x="9043187" y="5449824"/>
-            <a:ext cx="2782747" cy="1243584"/>
-          </a:xfrm>
-          <a:prstGeom prst="rect">
-            <a:avLst/>
-          </a:prstGeom>
-          <a:solidFill>
-            <a:srgbClr val="FEF9C3"/>
-          </a:solidFill>
-          <a:ln>
-            <a:solidFill>
-              <a:srgbClr val="FBBF24"/>
-            </a:solidFill>
-          </a:ln>
-        </p:spPr>
-        <p:style>
-          <a:lnRef idx="1">
-            <a:schemeClr val="accent1"/>
-          </a:lnRef>
-          <a:fillRef idx="3">
-            <a:schemeClr val="accent1"/>
-          </a:fillRef>
-          <a:effectRef idx="2">
-            <a:schemeClr val="accent1"/>
-          </a:effectRef>
-          <a:fontRef idx="minor">
-            <a:schemeClr val="lt1"/>
-          </a:fontRef>
-        </p:style>
-        <p:txBody>
-          <a:bodyPr rtlCol="0" anchor="ctr"/>
-          <a:lstStyle/>
-          <a:p>
-            <a:pPr algn="ctr"/>
-          </a:p>
-        </p:txBody>
-      </p:sp>
-      <p:sp>
-        <p:nvSpPr>
-          <p:cNvPr id="82" name="TextBox 81"/>
-          <p:cNvSpPr txBox="1"/>
-          <p:nvPr/>
-        </p:nvSpPr>
-        <p:spPr>
-          <a:xfrm>
-            <a:off x="9171203" y="5596128"/>
-            <a:ext cx="2526715" cy="274320"/>
-          </a:xfrm>
-          <a:prstGeom prst="rect">
-            <a:avLst/>
-          </a:prstGeom>
-          <a:noFill/>
-        </p:spPr>
-        <p:txBody>
-          <a:bodyPr wrap="square" lIns="0" rIns="0" tIns="0" bIns="0">
-            <a:spAutoFit/>
-          </a:bodyPr>
-          <a:lstStyle/>
-          <a:p>
-            <a:r>
-              <a:rPr sz="1000" b="1" i="0">
-                <a:solidFill>
-                  <a:srgbClr val="78350F"/>
-                </a:solidFill>
-                <a:latin typeface="Calibri"/>
-              </a:rPr>
-              <a:t>THE VALUE</a:t>
-            </a:r>
-          </a:p>
-        </p:txBody>
-      </p:sp>
-      <p:sp>
-        <p:nvSpPr>
-          <p:cNvPr id="83" name="TextBox 82"/>
-          <p:cNvSpPr txBox="1"/>
-          <p:nvPr/>
-        </p:nvSpPr>
-        <p:spPr>
-          <a:xfrm>
-            <a:off x="9171203" y="5907024"/>
-            <a:ext cx="2526715" cy="694944"/>
-          </a:xfrm>
-          <a:prstGeom prst="rect">
-            <a:avLst/>
-          </a:prstGeom>
-          <a:noFill/>
-        </p:spPr>
-        <p:txBody>
-          <a:bodyPr wrap="square" lIns="0" rIns="0" tIns="0" bIns="0">
-            <a:spAutoFit/>
-          </a:bodyPr>
-          <a:lstStyle/>
-          <a:p>
-            <a:r>
-              <a:rPr sz="1050" b="1" i="0">
-                <a:solidFill>
-                  <a:srgbClr val="78350F"/>
-                </a:solidFill>
-                <a:latin typeface="Calibri"/>
-              </a:rPr>
-              <a:t>One GM. One workday.
-From morning briefing to a live HTML dashboard — without leaving Microsoft 365.</a:t>
+              <a:t>THE VALUE: from morning briefing to a board-ready management paper · without leaving Microsoft 365.</a:t>
             </a:r>
           </a:p>
         </p:txBody>

</xml_diff>